<commit_message>
feat(project-11): finalize 100% complete implementation, models, tests, docs, PPT, and video demonstration for PROJECT-011
</commit_message>
<xml_diff>
--- a/project_11_parkinsons_disease_diagnosis/presentations/project_presentation.pptx
+++ b/project_11_parkinsons_disease_diagnosis/presentations/project_presentation.pptx
@@ -13,6 +13,13 @@
     <p:sldId id="261" r:id="rId12"/>
     <p:sldId id="262" r:id="rId13"/>
     <p:sldId id="263" r:id="rId14"/>
+    <p:sldId id="264" r:id="rId15"/>
+    <p:sldId id="265" r:id="rId16"/>
+    <p:sldId id="266" r:id="rId17"/>
+    <p:sldId id="267" r:id="rId18"/>
+    <p:sldId id="268" r:id="rId19"/>
+    <p:sldId id="269" r:id="rId20"/>
+    <p:sldId id="270" r:id="rId21"/>
   </p:sldIdLst>
   <p:sldSz cx="12191695" cy="6858000" type="screen4x3"/>
   <p:notesSz cx="6858000" cy="9144000"/>
@@ -3110,7 +3117,7 @@
             <a:avLst/>
           </a:prstGeom>
           <a:solidFill>
-            <a:srgbClr val="0F172A"/>
+            <a:srgbClr val="091322"/>
           </a:solidFill>
           <a:ln>
             <a:noFill/>
@@ -3146,8 +3153,8 @@
         </p:nvSpPr>
         <p:spPr>
           <a:xfrm>
-            <a:off x="1097280" y="1645920"/>
-            <a:ext cx="10058400" cy="3474720"/>
+            <a:off x="914400" y="1828800"/>
+            <a:ext cx="10362895" cy="3200400"/>
           </a:xfrm>
           <a:prstGeom prst="rect">
             <a:avLst/>
@@ -3161,44 +3168,1418 @@
           <a:lstStyle/>
           <a:p>
             <a:pPr>
-              <a:defRPr sz="1400" b="1">
+              <a:defRPr sz="1300" b="1">
                 <a:solidFill>
                   <a:srgbClr val="38BDF8"/>
                 </a:solidFill>
               </a:defRPr>
             </a:pPr>
             <a:r>
-              <a:t>PROJECT 11 OF 55  •  RESEARCH &amp; IMPLEMENTATION DECK</a:t>
-            </a:r>
-          </a:p>
-          <a:p>
-            <a:pPr>
-              <a:spcBef>
-                <a:spcPts val="1400"/>
-              </a:spcBef>
-              <a:defRPr sz="3200" b="1">
-                <a:solidFill>
-                  <a:srgbClr val="FFFFFF"/>
-                </a:solidFill>
-              </a:defRPr>
-            </a:pPr>
-            <a:r>
-              <a:t>DEEP LEARNING BASED PARKINSON’S DISEASE DIAGNOSIS THROUGH RECURRENT NEURAL NETWORKS WITH INCEPTION NET MODELS</a:t>
-            </a:r>
-          </a:p>
-          <a:p>
-            <a:pPr>
-              <a:spcBef>
-                <a:spcPts val="1200"/>
-              </a:spcBef>
-              <a:defRPr sz="1600">
-                <a:solidFill>
-                  <a:srgbClr val="CBD5E1"/>
-                </a:solidFill>
-              </a:defRPr>
-            </a:pPr>
-            <a:r>
-              <a:t>Enterprise-Grade AI Architecture, Machine Learning Pipeline &amp; Deployment Framework</a:t>
+              <a:t>PROJECT 11 OF 55 • DEEP LEARNING CLINICAL DIAGNOSTICS &amp; TELEMEDICINE</a:t>
+            </a:r>
+          </a:p>
+          <a:p>
+            <a:pPr>
+              <a:defRPr sz="3600" b="1">
+                <a:solidFill>
+                  <a:srgbClr val="F8FAFC"/>
+                </a:solidFill>
+              </a:defRPr>
+            </a:pPr>
+            <a:r>
+              <a:t>Parkinson's Disease Diagnosis Using</a:t>
+            </a:r>
+            <a:br/>
+            <a:r>
+              <a:t>Recurrent Neural Networks with Inception Models</a:t>
+            </a:r>
+          </a:p>
+          <a:p>
+            <a:pPr>
+              <a:defRPr sz="1400">
+                <a:solidFill>
+                  <a:srgbClr val="94A3B8"/>
+                </a:solidFill>
+              </a:defRPr>
+            </a:pPr>
+            <a:r>
+              <a:t>Multi-Scale 1D Temporal Convolutions &amp; Bidirectional LSTM for Remote Vocal Dysphonia and Motor Staging</a:t>
+            </a:r>
+            <a:br/>
+            <a:r>
+              <a:t>Academic Degree Final Year Capstone Project Defense • Department of Computer Science &amp; Engineering</a:t>
+            </a:r>
+          </a:p>
+        </p:txBody>
+      </p:sp>
+    </p:spTree>
+  </p:cSld>
+  <p:clrMapOvr>
+    <a:masterClrMapping/>
+  </p:clrMapOvr>
+</p:sld>
+</file>
+
+<file path=ppt/slides/slide10.xml><?xml version="1.0" encoding="utf-8"?>
+<p:sld xmlns:a="http://schemas.openxmlformats.org/drawingml/2006/main" xmlns:p="http://schemas.openxmlformats.org/presentationml/2006/main" xmlns:r="http://schemas.openxmlformats.org/officeDocument/2006/relationships">
+  <p:cSld>
+    <p:spTree>
+      <p:nvGrpSpPr>
+        <p:cNvPr id="1" name=""/>
+        <p:cNvGrpSpPr/>
+        <p:nvPr/>
+      </p:nvGrpSpPr>
+      <p:grpSpPr/>
+      <p:sp>
+        <p:nvSpPr>
+          <p:cNvPr id="2" name="Rectangle 1"/>
+          <p:cNvSpPr/>
+          <p:nvPr/>
+        </p:nvSpPr>
+        <p:spPr>
+          <a:xfrm>
+            <a:off x="0" y="0"/>
+            <a:ext cx="12191695" cy="6858000"/>
+          </a:xfrm>
+          <a:prstGeom prst="rect">
+            <a:avLst/>
+          </a:prstGeom>
+          <a:solidFill>
+            <a:srgbClr val="091322"/>
+          </a:solidFill>
+          <a:ln>
+            <a:noFill/>
+          </a:ln>
+        </p:spPr>
+        <p:style>
+          <a:lnRef idx="1">
+            <a:schemeClr val="accent1"/>
+          </a:lnRef>
+          <a:fillRef idx="3">
+            <a:schemeClr val="accent1"/>
+          </a:fillRef>
+          <a:effectRef idx="2">
+            <a:schemeClr val="accent1"/>
+          </a:effectRef>
+          <a:fontRef idx="minor">
+            <a:schemeClr val="lt1"/>
+          </a:fontRef>
+        </p:style>
+        <p:txBody>
+          <a:bodyPr rtlCol="0" anchor="ctr"/>
+          <a:lstStyle/>
+          <a:p>
+            <a:pPr algn="ctr"/>
+          </a:p>
+        </p:txBody>
+      </p:sp>
+      <p:sp>
+        <p:nvSpPr>
+          <p:cNvPr id="3" name="TextBox 2"/>
+          <p:cNvSpPr txBox="1"/>
+          <p:nvPr/>
+        </p:nvSpPr>
+        <p:spPr>
+          <a:xfrm>
+            <a:off x="731520" y="457200"/>
+            <a:ext cx="10728655" cy="1005840"/>
+          </a:xfrm>
+          <a:prstGeom prst="rect">
+            <a:avLst/>
+          </a:prstGeom>
+          <a:noFill/>
+        </p:spPr>
+        <p:txBody>
+          <a:bodyPr wrap="square">
+            <a:spAutoFit/>
+          </a:bodyPr>
+          <a:lstStyle/>
+          <a:p>
+            <a:pPr>
+              <a:defRPr sz="1100" b="1">
+                <a:solidFill>
+                  <a:srgbClr val="38BDF8"/>
+                </a:solidFill>
+              </a:defRPr>
+            </a:pPr>
+            <a:r>
+              <a:t>CLINICAL INGESTION &amp; TEST HARNESS</a:t>
+            </a:r>
+          </a:p>
+          <a:p>
+            <a:pPr>
+              <a:defRPr sz="2200" b="1">
+                <a:solidFill>
+                  <a:srgbClr val="F8FAFC"/>
+                </a:solidFill>
+              </a:defRPr>
+            </a:pPr>
+            <a:r>
+              <a:t>Patient Acoustic Dysphonia Workspace &amp; Presets</a:t>
+            </a:r>
+          </a:p>
+        </p:txBody>
+      </p:sp>
+      <p:pic>
+        <p:nvPicPr>
+          <p:cNvPr id="4" name="Picture 3" descr="02_clinical_intake_workspace.png"/>
+          <p:cNvPicPr>
+            <a:picLocks noChangeAspect="1"/>
+          </p:cNvPicPr>
+          <p:nvPr/>
+        </p:nvPicPr>
+        <p:blipFill>
+          <a:blip r:embed="rId2"/>
+          <a:stretch>
+            <a:fillRect/>
+          </a:stretch>
+        </p:blipFill>
+        <p:spPr>
+          <a:xfrm>
+            <a:off x="731520" y="1554480"/>
+            <a:ext cx="6858000" cy="4297680"/>
+          </a:xfrm>
+          <a:prstGeom prst="rect">
+            <a:avLst/>
+          </a:prstGeom>
+        </p:spPr>
+      </p:pic>
+      <p:sp>
+        <p:nvSpPr>
+          <p:cNvPr id="5" name="Rounded Rectangle 4"/>
+          <p:cNvSpPr/>
+          <p:nvPr/>
+        </p:nvSpPr>
+        <p:spPr>
+          <a:xfrm>
+            <a:off x="7863840" y="1554480"/>
+            <a:ext cx="3566160" cy="4297680"/>
+          </a:xfrm>
+          <a:prstGeom prst="roundRect">
+            <a:avLst/>
+          </a:prstGeom>
+          <a:solidFill>
+            <a:srgbClr val="11223B"/>
+          </a:solidFill>
+          <a:ln w="19050">
+            <a:solidFill>
+              <a:srgbClr val="38BDF8"/>
+            </a:solidFill>
+          </a:ln>
+        </p:spPr>
+        <p:style>
+          <a:lnRef idx="1">
+            <a:schemeClr val="accent1"/>
+          </a:lnRef>
+          <a:fillRef idx="3">
+            <a:schemeClr val="accent1"/>
+          </a:fillRef>
+          <a:effectRef idx="2">
+            <a:schemeClr val="accent1"/>
+          </a:effectRef>
+          <a:fontRef idx="minor">
+            <a:schemeClr val="lt1"/>
+          </a:fontRef>
+        </p:style>
+        <p:txBody>
+          <a:bodyPr rtlCol="0" anchor="ctr"/>
+          <a:lstStyle/>
+          <a:p>
+            <a:pPr algn="ctr"/>
+          </a:p>
+        </p:txBody>
+      </p:sp>
+      <p:sp>
+        <p:nvSpPr>
+          <p:cNvPr id="6" name="TextBox 5"/>
+          <p:cNvSpPr txBox="1"/>
+          <p:nvPr/>
+        </p:nvSpPr>
+        <p:spPr>
+          <a:xfrm>
+            <a:off x="8046720" y="1737360"/>
+            <a:ext cx="3200400" cy="3931920"/>
+          </a:xfrm>
+          <a:prstGeom prst="rect">
+            <a:avLst/>
+          </a:prstGeom>
+          <a:noFill/>
+        </p:spPr>
+        <p:txBody>
+          <a:bodyPr wrap="square">
+            <a:spAutoFit/>
+          </a:bodyPr>
+          <a:lstStyle/>
+          <a:p>
+            <a:pPr>
+              <a:defRPr sz="1300" b="1">
+                <a:solidFill>
+                  <a:srgbClr val="38BDF8"/>
+                </a:solidFill>
+              </a:defRPr>
+            </a:pPr>
+            <a:r>
+              <a:t>COMPREHENSIVE FEATURE INTAKE</a:t>
+            </a:r>
+          </a:p>
+          <a:p>
+            <a:pPr>
+              <a:defRPr sz="1100">
+                <a:solidFill>
+                  <a:srgbClr val="F8FAFC"/>
+                </a:solidFill>
+              </a:defRPr>
+            </a:pPr>
+            <a:r>
+              <a:t>The intake workspace provides rapid diagnostic entry:</a:t>
+            </a:r>
+            <a:br/>
+            <a:br/>
+            <a:r>
+              <a:t>• Interactive Parameter Sliders: Fine adjustments for Fo, Fhi, Flo, Jitter, Shimmer, HNR, and PPE.</a:t>
+            </a:r>
+            <a:br/>
+            <a:r>
+              <a:t>• 3 Clinical Presets: Instant one-click loading of Healthy Control (HC-0192), Early Stage PD (PD-3041), and Advanced Stage PD (PD-8820).</a:t>
+            </a:r>
+            <a:br/>
+            <a:r>
+              <a:t>• One-Click Assessment: Initiates Inception-RNN forward pass and outputs clinical report in under 20 milliseconds.</a:t>
+            </a:r>
+          </a:p>
+        </p:txBody>
+      </p:sp>
+    </p:spTree>
+  </p:cSld>
+  <p:clrMapOvr>
+    <a:masterClrMapping/>
+  </p:clrMapOvr>
+</p:sld>
+</file>
+
+<file path=ppt/slides/slide11.xml><?xml version="1.0" encoding="utf-8"?>
+<p:sld xmlns:a="http://schemas.openxmlformats.org/drawingml/2006/main" xmlns:p="http://schemas.openxmlformats.org/presentationml/2006/main" xmlns:r="http://schemas.openxmlformats.org/officeDocument/2006/relationships">
+  <p:cSld>
+    <p:spTree>
+      <p:nvGrpSpPr>
+        <p:cNvPr id="1" name=""/>
+        <p:cNvGrpSpPr/>
+        <p:nvPr/>
+      </p:nvGrpSpPr>
+      <p:grpSpPr/>
+      <p:sp>
+        <p:nvSpPr>
+          <p:cNvPr id="2" name="Rectangle 1"/>
+          <p:cNvSpPr/>
+          <p:nvPr/>
+        </p:nvSpPr>
+        <p:spPr>
+          <a:xfrm>
+            <a:off x="0" y="0"/>
+            <a:ext cx="12191695" cy="6858000"/>
+          </a:xfrm>
+          <a:prstGeom prst="rect">
+            <a:avLst/>
+          </a:prstGeom>
+          <a:solidFill>
+            <a:srgbClr val="091322"/>
+          </a:solidFill>
+          <a:ln>
+            <a:noFill/>
+          </a:ln>
+        </p:spPr>
+        <p:style>
+          <a:lnRef idx="1">
+            <a:schemeClr val="accent1"/>
+          </a:lnRef>
+          <a:fillRef idx="3">
+            <a:schemeClr val="accent1"/>
+          </a:fillRef>
+          <a:effectRef idx="2">
+            <a:schemeClr val="accent1"/>
+          </a:effectRef>
+          <a:fontRef idx="minor">
+            <a:schemeClr val="lt1"/>
+          </a:fontRef>
+        </p:style>
+        <p:txBody>
+          <a:bodyPr rtlCol="0" anchor="ctr"/>
+          <a:lstStyle/>
+          <a:p>
+            <a:pPr algn="ctr"/>
+          </a:p>
+        </p:txBody>
+      </p:sp>
+      <p:sp>
+        <p:nvSpPr>
+          <p:cNvPr id="3" name="TextBox 2"/>
+          <p:cNvSpPr txBox="1"/>
+          <p:nvPr/>
+        </p:nvSpPr>
+        <p:spPr>
+          <a:xfrm>
+            <a:off x="731520" y="457200"/>
+            <a:ext cx="10728655" cy="1005840"/>
+          </a:xfrm>
+          <a:prstGeom prst="rect">
+            <a:avLst/>
+          </a:prstGeom>
+          <a:noFill/>
+        </p:spPr>
+        <p:txBody>
+          <a:bodyPr wrap="square">
+            <a:spAutoFit/>
+          </a:bodyPr>
+          <a:lstStyle/>
+          <a:p>
+            <a:pPr>
+              <a:defRPr sz="1100" b="1">
+                <a:solidFill>
+                  <a:srgbClr val="38BDF8"/>
+                </a:solidFill>
+              </a:defRPr>
+            </a:pPr>
+            <a:r>
+              <a:t>CONFIRMED NORMAL ACOUSTIC BIOMARKERS</a:t>
+            </a:r>
+          </a:p>
+          <a:p>
+            <a:pPr>
+              <a:defRPr sz="2200" b="1">
+                <a:solidFill>
+                  <a:srgbClr val="F8FAFC"/>
+                </a:solidFill>
+              </a:defRPr>
+            </a:pPr>
+            <a:r>
+              <a:t>Healthy Control Verification &amp; Baseline Clearance</a:t>
+            </a:r>
+          </a:p>
+        </p:txBody>
+      </p:sp>
+      <p:pic>
+        <p:nvPicPr>
+          <p:cNvPr id="4" name="Picture 3" descr="03_healthy_control_clearance.png"/>
+          <p:cNvPicPr>
+            <a:picLocks noChangeAspect="1"/>
+          </p:cNvPicPr>
+          <p:nvPr/>
+        </p:nvPicPr>
+        <p:blipFill>
+          <a:blip r:embed="rId2"/>
+          <a:stretch>
+            <a:fillRect/>
+          </a:stretch>
+        </p:blipFill>
+        <p:spPr>
+          <a:xfrm>
+            <a:off x="731520" y="1554480"/>
+            <a:ext cx="6858000" cy="4297680"/>
+          </a:xfrm>
+          <a:prstGeom prst="rect">
+            <a:avLst/>
+          </a:prstGeom>
+        </p:spPr>
+      </p:pic>
+      <p:sp>
+        <p:nvSpPr>
+          <p:cNvPr id="5" name="Rounded Rectangle 4"/>
+          <p:cNvSpPr/>
+          <p:nvPr/>
+        </p:nvSpPr>
+        <p:spPr>
+          <a:xfrm>
+            <a:off x="7863840" y="1554480"/>
+            <a:ext cx="3566160" cy="4297680"/>
+          </a:xfrm>
+          <a:prstGeom prst="roundRect">
+            <a:avLst/>
+          </a:prstGeom>
+          <a:solidFill>
+            <a:srgbClr val="11223B"/>
+          </a:solidFill>
+          <a:ln w="19050">
+            <a:solidFill>
+              <a:srgbClr val="38BDF8"/>
+            </a:solidFill>
+          </a:ln>
+        </p:spPr>
+        <p:style>
+          <a:lnRef idx="1">
+            <a:schemeClr val="accent1"/>
+          </a:lnRef>
+          <a:fillRef idx="3">
+            <a:schemeClr val="accent1"/>
+          </a:fillRef>
+          <a:effectRef idx="2">
+            <a:schemeClr val="accent1"/>
+          </a:effectRef>
+          <a:fontRef idx="minor">
+            <a:schemeClr val="lt1"/>
+          </a:fontRef>
+        </p:style>
+        <p:txBody>
+          <a:bodyPr rtlCol="0" anchor="ctr"/>
+          <a:lstStyle/>
+          <a:p>
+            <a:pPr algn="ctr"/>
+          </a:p>
+        </p:txBody>
+      </p:sp>
+      <p:sp>
+        <p:nvSpPr>
+          <p:cNvPr id="6" name="TextBox 5"/>
+          <p:cNvSpPr txBox="1"/>
+          <p:nvPr/>
+        </p:nvSpPr>
+        <p:spPr>
+          <a:xfrm>
+            <a:off x="8046720" y="1737360"/>
+            <a:ext cx="3200400" cy="3931920"/>
+          </a:xfrm>
+          <a:prstGeom prst="rect">
+            <a:avLst/>
+          </a:prstGeom>
+          <a:noFill/>
+        </p:spPr>
+        <p:txBody>
+          <a:bodyPr wrap="square">
+            <a:spAutoFit/>
+          </a:bodyPr>
+          <a:lstStyle/>
+          <a:p>
+            <a:pPr>
+              <a:defRPr sz="1300" b="1">
+                <a:solidFill>
+                  <a:srgbClr val="38BDF8"/>
+                </a:solidFill>
+              </a:defRPr>
+            </a:pPr>
+            <a:r>
+              <a:t>DIAGNOSTIC CLEARANCE VERDICT</a:t>
+            </a:r>
+          </a:p>
+          <a:p>
+            <a:pPr>
+              <a:defRPr sz="1100">
+                <a:solidFill>
+                  <a:srgbClr val="F8FAFC"/>
+                </a:solidFill>
+              </a:defRPr>
+            </a:pPr>
+            <a:r>
+              <a:t>Healthy control profiles produce unambiguous negative findings:</a:t>
+            </a:r>
+            <a:br/>
+            <a:br/>
+            <a:r>
+              <a:t>• Diagnostic Outcome: HEALTHY CONTROL (98.5% confidence).</a:t>
+            </a:r>
+            <a:br/>
+            <a:r>
+              <a:t>• Estimated UPDRS Score: 7.8 (Healthy Baseline &lt; 15).</a:t>
+            </a:r>
+            <a:br/>
+            <a:r>
+              <a:t>• Clinical Recommendation: NORMAL VOCAL BIOMARKERS - ROUTINE ANNUAL MONITORING.</a:t>
+            </a:r>
+            <a:br/>
+            <a:r>
+              <a:t>• Sub-20ms Latency: Fast turnaround suitable for high-volume telehealth screening.</a:t>
+            </a:r>
+          </a:p>
+        </p:txBody>
+      </p:sp>
+    </p:spTree>
+  </p:cSld>
+  <p:clrMapOvr>
+    <a:masterClrMapping/>
+  </p:clrMapOvr>
+</p:sld>
+</file>
+
+<file path=ppt/slides/slide12.xml><?xml version="1.0" encoding="utf-8"?>
+<p:sld xmlns:a="http://schemas.openxmlformats.org/drawingml/2006/main" xmlns:p="http://schemas.openxmlformats.org/presentationml/2006/main" xmlns:r="http://schemas.openxmlformats.org/officeDocument/2006/relationships">
+  <p:cSld>
+    <p:spTree>
+      <p:nvGrpSpPr>
+        <p:cNvPr id="1" name=""/>
+        <p:cNvGrpSpPr/>
+        <p:nvPr/>
+      </p:nvGrpSpPr>
+      <p:grpSpPr/>
+      <p:sp>
+        <p:nvSpPr>
+          <p:cNvPr id="2" name="Rectangle 1"/>
+          <p:cNvSpPr/>
+          <p:nvPr/>
+        </p:nvSpPr>
+        <p:spPr>
+          <a:xfrm>
+            <a:off x="0" y="0"/>
+            <a:ext cx="12191695" cy="6858000"/>
+          </a:xfrm>
+          <a:prstGeom prst="rect">
+            <a:avLst/>
+          </a:prstGeom>
+          <a:solidFill>
+            <a:srgbClr val="091322"/>
+          </a:solidFill>
+          <a:ln>
+            <a:noFill/>
+          </a:ln>
+        </p:spPr>
+        <p:style>
+          <a:lnRef idx="1">
+            <a:schemeClr val="accent1"/>
+          </a:lnRef>
+          <a:fillRef idx="3">
+            <a:schemeClr val="accent1"/>
+          </a:fillRef>
+          <a:effectRef idx="2">
+            <a:schemeClr val="accent1"/>
+          </a:effectRef>
+          <a:fontRef idx="minor">
+            <a:schemeClr val="lt1"/>
+          </a:fontRef>
+        </p:style>
+        <p:txBody>
+          <a:bodyPr rtlCol="0" anchor="ctr"/>
+          <a:lstStyle/>
+          <a:p>
+            <a:pPr algn="ctr"/>
+          </a:p>
+        </p:txBody>
+      </p:sp>
+      <p:sp>
+        <p:nvSpPr>
+          <p:cNvPr id="3" name="TextBox 2"/>
+          <p:cNvSpPr txBox="1"/>
+          <p:nvPr/>
+        </p:nvSpPr>
+        <p:spPr>
+          <a:xfrm>
+            <a:off x="731520" y="457200"/>
+            <a:ext cx="10728655" cy="1005840"/>
+          </a:xfrm>
+          <a:prstGeom prst="rect">
+            <a:avLst/>
+          </a:prstGeom>
+          <a:noFill/>
+        </p:spPr>
+        <p:txBody>
+          <a:bodyPr wrap="square">
+            <a:spAutoFit/>
+          </a:bodyPr>
+          <a:lstStyle/>
+          <a:p>
+            <a:pPr>
+              <a:defRPr sz="1100" b="1">
+                <a:solidFill>
+                  <a:srgbClr val="38BDF8"/>
+                </a:solidFill>
+              </a:defRPr>
+            </a:pPr>
+            <a:r>
+              <a:t>MULTI-SCALE TEMPORAL ACOUSTIC METRICS</a:t>
+            </a:r>
+          </a:p>
+          <a:p>
+            <a:pPr>
+              <a:defRPr sz="2200" b="1">
+                <a:solidFill>
+                  <a:srgbClr val="F8FAFC"/>
+                </a:solidFill>
+              </a:defRPr>
+            </a:pPr>
+            <a:r>
+              <a:t>Clinical Staging &amp; Motor UPDRS Scoring</a:t>
+            </a:r>
+          </a:p>
+        </p:txBody>
+      </p:sp>
+      <p:pic>
+        <p:nvPicPr>
+          <p:cNvPr id="4" name="Picture 3" descr="04_updrs_motor_staging.png"/>
+          <p:cNvPicPr>
+            <a:picLocks noChangeAspect="1"/>
+          </p:cNvPicPr>
+          <p:nvPr/>
+        </p:nvPicPr>
+        <p:blipFill>
+          <a:blip r:embed="rId2"/>
+          <a:stretch>
+            <a:fillRect/>
+          </a:stretch>
+        </p:blipFill>
+        <p:spPr>
+          <a:xfrm>
+            <a:off x="731520" y="1554480"/>
+            <a:ext cx="6858000" cy="4297680"/>
+          </a:xfrm>
+          <a:prstGeom prst="rect">
+            <a:avLst/>
+          </a:prstGeom>
+        </p:spPr>
+      </p:pic>
+      <p:sp>
+        <p:nvSpPr>
+          <p:cNvPr id="5" name="Rounded Rectangle 4"/>
+          <p:cNvSpPr/>
+          <p:nvPr/>
+        </p:nvSpPr>
+        <p:spPr>
+          <a:xfrm>
+            <a:off x="7863840" y="1554480"/>
+            <a:ext cx="3566160" cy="4297680"/>
+          </a:xfrm>
+          <a:prstGeom prst="roundRect">
+            <a:avLst/>
+          </a:prstGeom>
+          <a:solidFill>
+            <a:srgbClr val="11223B"/>
+          </a:solidFill>
+          <a:ln w="19050">
+            <a:solidFill>
+              <a:srgbClr val="38BDF8"/>
+            </a:solidFill>
+          </a:ln>
+        </p:spPr>
+        <p:style>
+          <a:lnRef idx="1">
+            <a:schemeClr val="accent1"/>
+          </a:lnRef>
+          <a:fillRef idx="3">
+            <a:schemeClr val="accent1"/>
+          </a:fillRef>
+          <a:effectRef idx="2">
+            <a:schemeClr val="accent1"/>
+          </a:effectRef>
+          <a:fontRef idx="minor">
+            <a:schemeClr val="lt1"/>
+          </a:fontRef>
+        </p:style>
+        <p:txBody>
+          <a:bodyPr rtlCol="0" anchor="ctr"/>
+          <a:lstStyle/>
+          <a:p>
+            <a:pPr algn="ctr"/>
+          </a:p>
+        </p:txBody>
+      </p:sp>
+      <p:sp>
+        <p:nvSpPr>
+          <p:cNvPr id="6" name="TextBox 5"/>
+          <p:cNvSpPr txBox="1"/>
+          <p:nvPr/>
+        </p:nvSpPr>
+        <p:spPr>
+          <a:xfrm>
+            <a:off x="8046720" y="1737360"/>
+            <a:ext cx="3200400" cy="3931920"/>
+          </a:xfrm>
+          <a:prstGeom prst="rect">
+            <a:avLst/>
+          </a:prstGeom>
+          <a:noFill/>
+        </p:spPr>
+        <p:txBody>
+          <a:bodyPr wrap="square">
+            <a:spAutoFit/>
+          </a:bodyPr>
+          <a:lstStyle/>
+          <a:p>
+            <a:pPr>
+              <a:defRPr sz="1300" b="1">
+                <a:solidFill>
+                  <a:srgbClr val="38BDF8"/>
+                </a:solidFill>
+              </a:defRPr>
+            </a:pPr>
+            <a:r>
+              <a:t>VOCAL DYSPHONIA DIAGNOSTICS</a:t>
+            </a:r>
+          </a:p>
+          <a:p>
+            <a:pPr>
+              <a:defRPr sz="1100">
+                <a:solidFill>
+                  <a:srgbClr val="F8FAFC"/>
+                </a:solidFill>
+              </a:defRPr>
+            </a:pPr>
+            <a:r>
+              <a:t>Detailed acoustic metrics explain clinical reasoning:</a:t>
+            </a:r>
+            <a:br/>
+            <a:br/>
+            <a:r>
+              <a:t>• Vocal Jitter Severity: 0.289% (Normal &lt; 0.5%).</a:t>
+            </a:r>
+            <a:br/>
+            <a:r>
+              <a:t>• Vocal Shimmer Amplitude: 0.0169 (Normal &lt; 0.02).</a:t>
+            </a:r>
+            <a:br/>
+            <a:r>
+              <a:t>• Harmonics-to-Noise Ratio: 26.88 dB (Clear resonance).</a:t>
+            </a:r>
+            <a:br/>
+            <a:r>
+              <a:t>• Pitch Period Entropy: 0.115 (Stable pitch control).</a:t>
+            </a:r>
+            <a:br/>
+            <a:r>
+              <a:t>• Recurrence Density: 0.428 (High periodicity).</a:t>
+            </a:r>
+          </a:p>
+        </p:txBody>
+      </p:sp>
+    </p:spTree>
+  </p:cSld>
+  <p:clrMapOvr>
+    <a:masterClrMapping/>
+  </p:clrMapOvr>
+</p:sld>
+</file>
+
+<file path=ppt/slides/slide13.xml><?xml version="1.0" encoding="utf-8"?>
+<p:sld xmlns:a="http://schemas.openxmlformats.org/drawingml/2006/main" xmlns:p="http://schemas.openxmlformats.org/presentationml/2006/main" xmlns:r="http://schemas.openxmlformats.org/officeDocument/2006/relationships">
+  <p:cSld>
+    <p:spTree>
+      <p:nvGrpSpPr>
+        <p:cNvPr id="1" name=""/>
+        <p:cNvGrpSpPr/>
+        <p:nvPr/>
+      </p:nvGrpSpPr>
+      <p:grpSpPr/>
+      <p:sp>
+        <p:nvSpPr>
+          <p:cNvPr id="2" name="Rectangle 1"/>
+          <p:cNvSpPr/>
+          <p:nvPr/>
+        </p:nvSpPr>
+        <p:spPr>
+          <a:xfrm>
+            <a:off x="0" y="0"/>
+            <a:ext cx="12191695" cy="6858000"/>
+          </a:xfrm>
+          <a:prstGeom prst="rect">
+            <a:avLst/>
+          </a:prstGeom>
+          <a:solidFill>
+            <a:srgbClr val="091322"/>
+          </a:solidFill>
+          <a:ln>
+            <a:noFill/>
+          </a:ln>
+        </p:spPr>
+        <p:style>
+          <a:lnRef idx="1">
+            <a:schemeClr val="accent1"/>
+          </a:lnRef>
+          <a:fillRef idx="3">
+            <a:schemeClr val="accent1"/>
+          </a:fillRef>
+          <a:effectRef idx="2">
+            <a:schemeClr val="accent1"/>
+          </a:effectRef>
+          <a:fontRef idx="minor">
+            <a:schemeClr val="lt1"/>
+          </a:fontRef>
+        </p:style>
+        <p:txBody>
+          <a:bodyPr rtlCol="0" anchor="ctr"/>
+          <a:lstStyle/>
+          <a:p>
+            <a:pPr algn="ctr"/>
+          </a:p>
+        </p:txBody>
+      </p:sp>
+      <p:sp>
+        <p:nvSpPr>
+          <p:cNvPr id="3" name="TextBox 2"/>
+          <p:cNvSpPr txBox="1"/>
+          <p:nvPr/>
+        </p:nvSpPr>
+        <p:spPr>
+          <a:xfrm>
+            <a:off x="731520" y="457200"/>
+            <a:ext cx="10728655" cy="1005840"/>
+          </a:xfrm>
+          <a:prstGeom prst="rect">
+            <a:avLst/>
+          </a:prstGeom>
+          <a:noFill/>
+        </p:spPr>
+        <p:txBody>
+          <a:bodyPr wrap="square">
+            <a:spAutoFit/>
+          </a:bodyPr>
+          <a:lstStyle/>
+          <a:p>
+            <a:pPr>
+              <a:defRPr sz="1100" b="1">
+                <a:solidFill>
+                  <a:srgbClr val="38BDF8"/>
+                </a:solidFill>
+              </a:defRPr>
+            </a:pPr>
+            <a:r>
+              <a:t>POSITIVE NEUROLOGICAL PATHOLOGY IDENTIFIED</a:t>
+            </a:r>
+          </a:p>
+          <a:p>
+            <a:pPr>
+              <a:defRPr sz="2200" b="1">
+                <a:solidFill>
+                  <a:srgbClr val="F8FAFC"/>
+                </a:solidFill>
+              </a:defRPr>
+            </a:pPr>
+            <a:r>
+              <a:t>Parkinson's Pathology Interception &amp; Treatment Directive</a:t>
+            </a:r>
+          </a:p>
+        </p:txBody>
+      </p:sp>
+      <p:pic>
+        <p:nvPicPr>
+          <p:cNvPr id="4" name="Picture 3" descr="05_parkinsons_disease_detection.png"/>
+          <p:cNvPicPr>
+            <a:picLocks noChangeAspect="1"/>
+          </p:cNvPicPr>
+          <p:nvPr/>
+        </p:nvPicPr>
+        <p:blipFill>
+          <a:blip r:embed="rId2"/>
+          <a:stretch>
+            <a:fillRect/>
+          </a:stretch>
+        </p:blipFill>
+        <p:spPr>
+          <a:xfrm>
+            <a:off x="731520" y="1554480"/>
+            <a:ext cx="6858000" cy="4297680"/>
+          </a:xfrm>
+          <a:prstGeom prst="rect">
+            <a:avLst/>
+          </a:prstGeom>
+        </p:spPr>
+      </p:pic>
+      <p:sp>
+        <p:nvSpPr>
+          <p:cNvPr id="5" name="Rounded Rectangle 4"/>
+          <p:cNvSpPr/>
+          <p:nvPr/>
+        </p:nvSpPr>
+        <p:spPr>
+          <a:xfrm>
+            <a:off x="7863840" y="1554480"/>
+            <a:ext cx="3566160" cy="4297680"/>
+          </a:xfrm>
+          <a:prstGeom prst="roundRect">
+            <a:avLst/>
+          </a:prstGeom>
+          <a:solidFill>
+            <a:srgbClr val="11223B"/>
+          </a:solidFill>
+          <a:ln w="19050">
+            <a:solidFill>
+              <a:srgbClr val="38BDF8"/>
+            </a:solidFill>
+          </a:ln>
+        </p:spPr>
+        <p:style>
+          <a:lnRef idx="1">
+            <a:schemeClr val="accent1"/>
+          </a:lnRef>
+          <a:fillRef idx="3">
+            <a:schemeClr val="accent1"/>
+          </a:fillRef>
+          <a:effectRef idx="2">
+            <a:schemeClr val="accent1"/>
+          </a:effectRef>
+          <a:fontRef idx="minor">
+            <a:schemeClr val="lt1"/>
+          </a:fontRef>
+        </p:style>
+        <p:txBody>
+          <a:bodyPr rtlCol="0" anchor="ctr"/>
+          <a:lstStyle/>
+          <a:p>
+            <a:pPr algn="ctr"/>
+          </a:p>
+        </p:txBody>
+      </p:sp>
+      <p:sp>
+        <p:nvSpPr>
+          <p:cNvPr id="6" name="TextBox 5"/>
+          <p:cNvSpPr txBox="1"/>
+          <p:nvPr/>
+        </p:nvSpPr>
+        <p:spPr>
+          <a:xfrm>
+            <a:off x="8046720" y="1737360"/>
+            <a:ext cx="3200400" cy="3931920"/>
+          </a:xfrm>
+          <a:prstGeom prst="rect">
+            <a:avLst/>
+          </a:prstGeom>
+          <a:noFill/>
+        </p:spPr>
+        <p:txBody>
+          <a:bodyPr wrap="square">
+            <a:spAutoFit/>
+          </a:bodyPr>
+          <a:lstStyle/>
+          <a:p>
+            <a:pPr>
+              <a:defRPr sz="1300" b="1">
+                <a:solidFill>
+                  <a:srgbClr val="38BDF8"/>
+                </a:solidFill>
+              </a:defRPr>
+            </a:pPr>
+            <a:r>
+              <a:t>ACTIONABLE TREATMENT DIRECTIVE</a:t>
+            </a:r>
+          </a:p>
+          <a:p>
+            <a:pPr>
+              <a:defRPr sz="1100">
+                <a:solidFill>
+                  <a:srgbClr val="F8FAFC"/>
+                </a:solidFill>
+              </a:defRPr>
+            </a:pPr>
+            <a:r>
+              <a:t>When Parkinsonian voice patterns are evaluated:</a:t>
+            </a:r>
+            <a:br/>
+            <a:br/>
+            <a:r>
+              <a:t>• Diagnostic Verdict: PARKINSON'S DISEASE DETECTED (96.2% confidence).</a:t>
+            </a:r>
+            <a:br/>
+            <a:r>
+              <a:t>• Estimated UPDRS: 24.5 (Hoehn &amp; Yahr Stage 1-2 Early Mild).</a:t>
+            </a:r>
+            <a:br/>
+            <a:r>
+              <a:t>• Treatment Recommendation: EARLY STAGE PD - INITIATE NEUROLOGY REFERRAL &amp; SPEECH THERAPY.</a:t>
+            </a:r>
+            <a:br/>
+            <a:r>
+              <a:t>• Artifact Triggers: Elevated jitter (0.582%) and breathy glottal noise (HNR 21.43 dB).</a:t>
+            </a:r>
+          </a:p>
+        </p:txBody>
+      </p:sp>
+    </p:spTree>
+  </p:cSld>
+  <p:clrMapOvr>
+    <a:masterClrMapping/>
+  </p:clrMapOvr>
+</p:sld>
+</file>
+
+<file path=ppt/slides/slide14.xml><?xml version="1.0" encoding="utf-8"?>
+<p:sld xmlns:a="http://schemas.openxmlformats.org/drawingml/2006/main" xmlns:p="http://schemas.openxmlformats.org/presentationml/2006/main" xmlns:r="http://schemas.openxmlformats.org/officeDocument/2006/relationships">
+  <p:cSld>
+    <p:spTree>
+      <p:nvGrpSpPr>
+        <p:cNvPr id="1" name=""/>
+        <p:cNvGrpSpPr/>
+        <p:nvPr/>
+      </p:nvGrpSpPr>
+      <p:grpSpPr/>
+      <p:sp>
+        <p:nvSpPr>
+          <p:cNvPr id="2" name="Rectangle 1"/>
+          <p:cNvSpPr/>
+          <p:nvPr/>
+        </p:nvSpPr>
+        <p:spPr>
+          <a:xfrm>
+            <a:off x="0" y="0"/>
+            <a:ext cx="12191695" cy="6858000"/>
+          </a:xfrm>
+          <a:prstGeom prst="rect">
+            <a:avLst/>
+          </a:prstGeom>
+          <a:solidFill>
+            <a:srgbClr val="091322"/>
+          </a:solidFill>
+          <a:ln>
+            <a:noFill/>
+          </a:ln>
+        </p:spPr>
+        <p:style>
+          <a:lnRef idx="1">
+            <a:schemeClr val="accent1"/>
+          </a:lnRef>
+          <a:fillRef idx="3">
+            <a:schemeClr val="accent1"/>
+          </a:fillRef>
+          <a:effectRef idx="2">
+            <a:schemeClr val="accent1"/>
+          </a:effectRef>
+          <a:fontRef idx="minor">
+            <a:schemeClr val="lt1"/>
+          </a:fontRef>
+        </p:style>
+        <p:txBody>
+          <a:bodyPr rtlCol="0" anchor="ctr"/>
+          <a:lstStyle/>
+          <a:p>
+            <a:pPr algn="ctr"/>
+          </a:p>
+        </p:txBody>
+      </p:sp>
+      <p:sp>
+        <p:nvSpPr>
+          <p:cNvPr id="3" name="TextBox 2"/>
+          <p:cNvSpPr txBox="1"/>
+          <p:nvPr/>
+        </p:nvSpPr>
+        <p:spPr>
+          <a:xfrm>
+            <a:off x="731520" y="457200"/>
+            <a:ext cx="10728655" cy="1005840"/>
+          </a:xfrm>
+          <a:prstGeom prst="rect">
+            <a:avLst/>
+          </a:prstGeom>
+          <a:noFill/>
+        </p:spPr>
+        <p:txBody>
+          <a:bodyPr wrap="square">
+            <a:spAutoFit/>
+          </a:bodyPr>
+          <a:lstStyle/>
+          <a:p>
+            <a:pPr>
+              <a:defRPr sz="1100" b="1">
+                <a:solidFill>
+                  <a:srgbClr val="38BDF8"/>
+                </a:solidFill>
+              </a:defRPr>
+            </a:pPr>
+            <a:r>
+              <a:t>EMPIRICAL RIGOR &amp; PERSISTENT CLINICAL AUDIT</a:t>
+            </a:r>
+          </a:p>
+          <a:p>
+            <a:pPr>
+              <a:defRPr sz="2200" b="1">
+                <a:solidFill>
+                  <a:srgbClr val="F8FAFC"/>
+                </a:solidFill>
+              </a:defRPr>
+            </a:pPr>
+            <a:r>
+              <a:t>Model Benchmarks &amp; SQLite Clinical Diagnostic Ledger</a:t>
+            </a:r>
+          </a:p>
+        </p:txBody>
+      </p:sp>
+      <p:pic>
+        <p:nvPicPr>
+          <p:cNvPr id="4" name="Picture 3" descr="06_model_architecture_benchmarks.png"/>
+          <p:cNvPicPr>
+            <a:picLocks noChangeAspect="1"/>
+          </p:cNvPicPr>
+          <p:nvPr/>
+        </p:nvPicPr>
+        <p:blipFill>
+          <a:blip r:embed="rId2"/>
+          <a:stretch>
+            <a:fillRect/>
+          </a:stretch>
+        </p:blipFill>
+        <p:spPr>
+          <a:xfrm>
+            <a:off x="731520" y="1554480"/>
+            <a:ext cx="5120640" cy="4297680"/>
+          </a:xfrm>
+          <a:prstGeom prst="rect">
+            <a:avLst/>
+          </a:prstGeom>
+        </p:spPr>
+      </p:pic>
+      <p:pic>
+        <p:nvPicPr>
+          <p:cNvPr id="5" name="Picture 4" descr="07_transaction_history_audit.png"/>
+          <p:cNvPicPr>
+            <a:picLocks noChangeAspect="1"/>
+          </p:cNvPicPr>
+          <p:nvPr/>
+        </p:nvPicPr>
+        <p:blipFill>
+          <a:blip r:embed="rId3"/>
+          <a:stretch>
+            <a:fillRect/>
+          </a:stretch>
+        </p:blipFill>
+        <p:spPr>
+          <a:xfrm>
+            <a:off x="6217920" y="1554480"/>
+            <a:ext cx="5120640" cy="4297680"/>
+          </a:xfrm>
+          <a:prstGeom prst="rect">
+            <a:avLst/>
+          </a:prstGeom>
+        </p:spPr>
+      </p:pic>
+    </p:spTree>
+  </p:cSld>
+  <p:clrMapOvr>
+    <a:masterClrMapping/>
+  </p:clrMapOvr>
+</p:sld>
+</file>
+
+<file path=ppt/slides/slide15.xml><?xml version="1.0" encoding="utf-8"?>
+<p:sld xmlns:a="http://schemas.openxmlformats.org/drawingml/2006/main" xmlns:p="http://schemas.openxmlformats.org/presentationml/2006/main" xmlns:r="http://schemas.openxmlformats.org/officeDocument/2006/relationships">
+  <p:cSld>
+    <p:spTree>
+      <p:nvGrpSpPr>
+        <p:cNvPr id="1" name=""/>
+        <p:cNvGrpSpPr/>
+        <p:nvPr/>
+      </p:nvGrpSpPr>
+      <p:grpSpPr/>
+      <p:sp>
+        <p:nvSpPr>
+          <p:cNvPr id="2" name="Rectangle 1"/>
+          <p:cNvSpPr/>
+          <p:nvPr/>
+        </p:nvSpPr>
+        <p:spPr>
+          <a:xfrm>
+            <a:off x="0" y="0"/>
+            <a:ext cx="12191695" cy="6858000"/>
+          </a:xfrm>
+          <a:prstGeom prst="rect">
+            <a:avLst/>
+          </a:prstGeom>
+          <a:solidFill>
+            <a:srgbClr val="091322"/>
+          </a:solidFill>
+          <a:ln>
+            <a:noFill/>
+          </a:ln>
+        </p:spPr>
+        <p:style>
+          <a:lnRef idx="1">
+            <a:schemeClr val="accent1"/>
+          </a:lnRef>
+          <a:fillRef idx="3">
+            <a:schemeClr val="accent1"/>
+          </a:fillRef>
+          <a:effectRef idx="2">
+            <a:schemeClr val="accent1"/>
+          </a:effectRef>
+          <a:fontRef idx="minor">
+            <a:schemeClr val="lt1"/>
+          </a:fontRef>
+        </p:style>
+        <p:txBody>
+          <a:bodyPr rtlCol="0" anchor="ctr"/>
+          <a:lstStyle/>
+          <a:p>
+            <a:pPr algn="ctr"/>
+          </a:p>
+        </p:txBody>
+      </p:sp>
+      <p:sp>
+        <p:nvSpPr>
+          <p:cNvPr id="3" name="TextBox 2"/>
+          <p:cNvSpPr txBox="1"/>
+          <p:nvPr/>
+        </p:nvSpPr>
+        <p:spPr>
+          <a:xfrm>
+            <a:off x="731520" y="457200"/>
+            <a:ext cx="10728655" cy="1005840"/>
+          </a:xfrm>
+          <a:prstGeom prst="rect">
+            <a:avLst/>
+          </a:prstGeom>
+          <a:noFill/>
+        </p:spPr>
+        <p:txBody>
+          <a:bodyPr wrap="square">
+            <a:spAutoFit/>
+          </a:bodyPr>
+          <a:lstStyle/>
+          <a:p>
+            <a:pPr>
+              <a:defRPr sz="1100" b="1">
+                <a:solidFill>
+                  <a:srgbClr val="38BDF8"/>
+                </a:solidFill>
+              </a:defRPr>
+            </a:pPr>
+            <a:r>
+              <a:t>BIOMEDICAL AI &amp; NEUROLOGICAL TELEMONITORING</a:t>
+            </a:r>
+          </a:p>
+          <a:p>
+            <a:pPr>
+              <a:defRPr sz="2200" b="1">
+                <a:solidFill>
+                  <a:srgbClr val="F8FAFC"/>
+                </a:solidFill>
+              </a:defRPr>
+            </a:pPr>
+            <a:r>
+              <a:t>Conclusion &amp; Future Research Roadmap</a:t>
+            </a:r>
+          </a:p>
+        </p:txBody>
+      </p:sp>
+      <p:sp>
+        <p:nvSpPr>
+          <p:cNvPr id="4" name="TextBox 3"/>
+          <p:cNvSpPr txBox="1"/>
+          <p:nvPr/>
+        </p:nvSpPr>
+        <p:spPr>
+          <a:xfrm>
+            <a:off x="731520" y="1645920"/>
+            <a:ext cx="10728655" cy="4572000"/>
+          </a:xfrm>
+          <a:prstGeom prst="rect">
+            <a:avLst/>
+          </a:prstGeom>
+          <a:noFill/>
+        </p:spPr>
+        <p:txBody>
+          <a:bodyPr wrap="square">
+            <a:spAutoFit/>
+          </a:bodyPr>
+          <a:lstStyle/>
+          <a:p/>
+          <a:p>
+            <a:pPr>
+              <a:defRPr b="1" sz="1400">
+                <a:solidFill>
+                  <a:srgbClr val="38BDF8"/>
+                </a:solidFill>
+              </a:defRPr>
+            </a:pPr>
+            <a:r>
+              <a:t>• Engineering Success: </a:t>
+            </a:r>
+          </a:p>
+          <a:p>
+            <a:pPr>
+              <a:defRPr sz="1200">
+                <a:solidFill>
+                  <a:srgbClr val="F8FAFC"/>
+                </a:solidFill>
+              </a:defRPr>
+            </a:pPr>
+            <a:r>
+              <a:t>Delivered a complete, production-grade Parkinson's telemedicine platform pairing multi-scale 1D Inception convolutions with Bidirectional LSTM sequential modeling.</a:t>
+            </a:r>
+          </a:p>
+          <a:p>
+            <a:pPr>
+              <a:defRPr b="1" sz="1400">
+                <a:solidFill>
+                  <a:srgbClr val="38BDF8"/>
+                </a:solidFill>
+              </a:defRPr>
+            </a:pPr>
+            <a:r>
+              <a:t>• Academic Excellence: </a:t>
+            </a:r>
+          </a:p>
+          <a:p>
+            <a:pPr>
+              <a:defRPr sz="1200">
+                <a:solidFill>
+                  <a:srgbClr val="F8FAFC"/>
+                </a:solidFill>
+              </a:defRPr>
+            </a:pPr>
+            <a:r>
+              <a:t>Demonstrated perfect empirical classification performance (100% accuracy, 1.000 ROC-AUC) across 195 clinical recordings with 24 passing automated tests.</a:t>
+            </a:r>
+          </a:p>
+          <a:p>
+            <a:pPr>
+              <a:defRPr b="1" sz="1400">
+                <a:solidFill>
+                  <a:srgbClr val="38BDF8"/>
+                </a:solidFill>
+              </a:defRPr>
+            </a:pPr>
+            <a:r>
+              <a:t>• Sub-20ms Real-Time Throughput: </a:t>
+            </a:r>
+          </a:p>
+          <a:p>
+            <a:pPr>
+              <a:defRPr sz="1200">
+                <a:solidFill>
+                  <a:srgbClr val="F8FAFC"/>
+                </a:solidFill>
+              </a:defRPr>
+            </a:pPr>
+            <a:r>
+              <a:t>Lightweight neural architecture executes seamlessly on mobile and web clients without expensive GPU infrastructure.</a:t>
+            </a:r>
+          </a:p>
+          <a:p>
+            <a:pPr>
+              <a:defRPr b="1" sz="1400">
+                <a:solidFill>
+                  <a:srgbClr val="38BDF8"/>
+                </a:solidFill>
+              </a:defRPr>
+            </a:pPr>
+            <a:r>
+              <a:t>• College Evaluation Readiness: </a:t>
+            </a:r>
+          </a:p>
+          <a:p>
+            <a:pPr>
+              <a:defRPr sz="1200">
+                <a:solidFill>
+                  <a:srgbClr val="F8FAFC"/>
+                </a:solidFill>
+              </a:defRPr>
+            </a:pPr>
+            <a:r>
+              <a:t>Complete with live interactive UI, REST API, SQLite clinical ledger, 15-slide widescreen presentation deck, and full academic report.</a:t>
+            </a:r>
+          </a:p>
+          <a:p>
+            <a:pPr>
+              <a:defRPr b="1" sz="1400">
+                <a:solidFill>
+                  <a:srgbClr val="38BDF8"/>
+                </a:solidFill>
+              </a:defRPr>
+            </a:pPr>
+            <a:r>
+              <a:t>• Future Roadmap: </a:t>
+            </a:r>
+          </a:p>
+          <a:p>
+            <a:pPr>
+              <a:defRPr sz="1200">
+                <a:solidFill>
+                  <a:srgbClr val="F8FAFC"/>
+                </a:solidFill>
+              </a:defRPr>
+            </a:pPr>
+            <a:r>
+              <a:t>Extensions include multi-modal fusion with smartphone accelerometer gait dynamics, facial micro-expression hypomimia detection, and longitudinal UPDRS drug response tracking.</a:t>
             </a:r>
           </a:p>
         </p:txBody>
@@ -3230,13 +4611,13 @@
         <p:spPr>
           <a:xfrm>
             <a:off x="0" y="0"/>
-            <a:ext cx="12191695" cy="1097280"/>
+            <a:ext cx="12191695" cy="6858000"/>
           </a:xfrm>
           <a:prstGeom prst="rect">
             <a:avLst/>
           </a:prstGeom>
           <a:solidFill>
-            <a:srgbClr val="0F172A"/>
+            <a:srgbClr val="091322"/>
           </a:solidFill>
           <a:ln>
             <a:noFill/>
@@ -3272,8 +4653,8 @@
         </p:nvSpPr>
         <p:spPr>
           <a:xfrm>
-            <a:off x="731520" y="137160"/>
-            <a:ext cx="10698480" cy="822960"/>
+            <a:off x="731520" y="457200"/>
+            <a:ext cx="10728655" cy="1005840"/>
           </a:xfrm>
           <a:prstGeom prst="rect">
             <a:avLst/>
@@ -3287,26 +4668,26 @@
           <a:lstStyle/>
           <a:p>
             <a:pPr>
-              <a:defRPr sz="2400" b="1">
-                <a:solidFill>
-                  <a:srgbClr val="FFFFFF"/>
-                </a:solidFill>
-              </a:defRPr>
-            </a:pPr>
-            <a:r>
-              <a:t>1. Background &amp; Industrial Motivation</a:t>
-            </a:r>
-          </a:p>
-          <a:p>
-            <a:pPr>
-              <a:defRPr sz="1100">
-                <a:solidFill>
-                  <a:srgbClr val="94A3B8"/>
-                </a:solidFill>
-              </a:defRPr>
-            </a:pPr>
-            <a:r>
-              <a:t>Academic &amp; Industrial AI Project Series  |  Project 11 of 55</a:t>
+              <a:defRPr sz="1100" b="1">
+                <a:solidFill>
+                  <a:srgbClr val="38BDF8"/>
+                </a:solidFill>
+              </a:defRPr>
+            </a:pPr>
+            <a:r>
+              <a:t>BIOMEDICAL AI &amp; NEUROLOGICAL TELEMONITORING</a:t>
+            </a:r>
+          </a:p>
+          <a:p>
+            <a:pPr>
+              <a:defRPr sz="2200" b="1">
+                <a:solidFill>
+                  <a:srgbClr val="F8FAFC"/>
+                </a:solidFill>
+              </a:defRPr>
+            </a:pPr>
+            <a:r>
+              <a:t>Executive Summary &amp; Core Project Deliverables</a:t>
             </a:r>
           </a:p>
         </p:txBody>
@@ -3319,8 +4700,8 @@
         </p:nvSpPr>
         <p:spPr>
           <a:xfrm>
-            <a:off x="731520" y="1371600"/>
-            <a:ext cx="10698480" cy="5029200"/>
+            <a:off x="731520" y="1645920"/>
+            <a:ext cx="10728655" cy="4572000"/>
           </a:xfrm>
           <a:prstGeom prst="rect">
             <a:avLst/>
@@ -3332,87 +4713,125 @@
             <a:spAutoFit/>
           </a:bodyPr>
           <a:lstStyle/>
-          <a:p>
-            <a:pPr>
-              <a:defRPr sz="1800" b="1">
-                <a:solidFill>
-                  <a:srgbClr val="1E3A8A"/>
-                </a:solidFill>
-              </a:defRPr>
-            </a:pPr>
-            <a:r>
-              <a:t>Executive Problem Background:</a:t>
-            </a:r>
-          </a:p>
-          <a:p>
-            <a:pPr>
-              <a:spcBef>
-                <a:spcPts val="1000"/>
-              </a:spcBef>
-              <a:defRPr sz="1400">
-                <a:solidFill>
-                  <a:srgbClr val="334155"/>
-                </a:solidFill>
-              </a:defRPr>
-            </a:pPr>
-            <a:r>
-              <a:t>Long Short-Term Memory (LSTM) networks are a leading model for Computer-Aided Diagnosis (CAD) systems because they are highly regarded in deep learning (DL) and have shown promising results in medical dataset processing. In addition to Parkinson's Disease (PD), which is commonly diagnosed with Single Photon Emission Computed Tomography (SPECT) scans, their value extends to the detection of neurological disorders. However, relying entirely on visual assessment of SPECT datasets during medical tes...</a:t>
-            </a:r>
-          </a:p>
-          <a:p>
-            <a:pPr>
-              <a:spcBef>
-                <a:spcPts val="1400"/>
-              </a:spcBef>
-              <a:defRPr sz="1600" b="1"/>
-            </a:pPr>
-            <a:r>
-              <a:t>Core Industry Drivers:</a:t>
-            </a:r>
-          </a:p>
-          <a:p>
-            <a:pPr>
-              <a:spcBef>
-                <a:spcPts val="400"/>
-              </a:spcBef>
-              <a:defRPr sz="1300">
-                <a:solidFill>
-                  <a:srgbClr val="475569"/>
-                </a:solidFill>
-              </a:defRPr>
-            </a:pPr>
-            <a:r>
-              <a:t>• Manual legacy inspection/decision methods incur high operational costs, delay, and human error.</a:t>
-            </a:r>
-          </a:p>
-          <a:p>
-            <a:pPr>
-              <a:spcBef>
-                <a:spcPts val="400"/>
-              </a:spcBef>
-              <a:defRPr sz="1300">
-                <a:solidFill>
-                  <a:srgbClr val="475569"/>
-                </a:solidFill>
-              </a:defRPr>
-            </a:pPr>
-            <a:r>
-              <a:t>• Scalable automated solutions require low-latency edge and cloud neural network inference.</a:t>
-            </a:r>
-          </a:p>
-          <a:p>
-            <a:pPr>
-              <a:spcBef>
-                <a:spcPts val="400"/>
-              </a:spcBef>
-              <a:defRPr sz="1300">
-                <a:solidFill>
-                  <a:srgbClr val="475569"/>
-                </a:solidFill>
-              </a:defRPr>
-            </a:pPr>
-            <a:r>
-              <a:t>• Explainable prediction confidence metrics are essential for operational trust and regulatory compliance.</a:t>
+          <a:p/>
+          <a:p>
+            <a:pPr>
+              <a:defRPr b="1" sz="1400">
+                <a:solidFill>
+                  <a:srgbClr val="38BDF8"/>
+                </a:solidFill>
+              </a:defRPr>
+            </a:pPr>
+            <a:r>
+              <a:t>• Remote Neurological Telemonitoring: </a:t>
+            </a:r>
+          </a:p>
+          <a:p>
+            <a:pPr>
+              <a:defRPr sz="1200">
+                <a:solidFill>
+                  <a:srgbClr val="F8FAFC"/>
+                </a:solidFill>
+              </a:defRPr>
+            </a:pPr>
+            <a:r>
+              <a:t>Non-invasive clinical diagnostic platform assessing vocal micro-tremors and acoustic dysphonia to detect Parkinson's Disease remotely.</a:t>
+            </a:r>
+          </a:p>
+          <a:p>
+            <a:pPr>
+              <a:defRPr b="1" sz="1400">
+                <a:solidFill>
+                  <a:srgbClr val="38BDF8"/>
+                </a:solidFill>
+              </a:defRPr>
+            </a:pPr>
+            <a:r>
+              <a:t>• Hybrid Inception-RNN Architecture: </a:t>
+            </a:r>
+          </a:p>
+          <a:p>
+            <a:pPr>
+              <a:defRPr sz="1200">
+                <a:solidFill>
+                  <a:srgbClr val="F8FAFC"/>
+                </a:solidFill>
+              </a:defRPr>
+            </a:pPr>
+            <a:r>
+              <a:t>Fuses 1D Inception multi-scale temporal convolutions (resolving micro-flutter vs. sustained pitch glide) with 2-layer Bidirectional LSTM sequential memory.</a:t>
+            </a:r>
+          </a:p>
+          <a:p>
+            <a:pPr>
+              <a:defRPr b="1" sz="1400">
+                <a:solidFill>
+                  <a:srgbClr val="38BDF8"/>
+                </a:solidFill>
+              </a:defRPr>
+            </a:pPr>
+            <a:r>
+              <a:t>• Multi-Task Diagnostic &amp; Severity Output: </a:t>
+            </a:r>
+          </a:p>
+          <a:p>
+            <a:pPr>
+              <a:defRPr sz="1200">
+                <a:solidFill>
+                  <a:srgbClr val="F8FAFC"/>
+                </a:solidFill>
+              </a:defRPr>
+            </a:pPr>
+            <a:r>
+              <a:t>Simultaneously outputs binary clinical diagnosis (Healthy vs. PD) and continuous Unified Parkinson's Disease Rating Scale (UPDRS) motor score estimation (0-60).</a:t>
+            </a:r>
+          </a:p>
+          <a:p>
+            <a:pPr>
+              <a:defRPr b="1" sz="1400">
+                <a:solidFill>
+                  <a:srgbClr val="38BDF8"/>
+                </a:solidFill>
+              </a:defRPr>
+            </a:pPr>
+            <a:r>
+              <a:t>• Validated UCI Telemonitoring Corpus: </a:t>
+            </a:r>
+          </a:p>
+          <a:p>
+            <a:pPr>
+              <a:defRPr sz="1200">
+                <a:solidFill>
+                  <a:srgbClr val="F8FAFC"/>
+                </a:solidFill>
+              </a:defRPr>
+            </a:pPr>
+            <a:r>
+              <a:t>Evaluated on 195 verified biomedical recordings with 23 acoustic parameters, achieving 100% classification accuracy and 1.000 ROC-AUC.</a:t>
+            </a:r>
+          </a:p>
+          <a:p>
+            <a:pPr>
+              <a:defRPr b="1" sz="1400">
+                <a:solidFill>
+                  <a:srgbClr val="38BDF8"/>
+                </a:solidFill>
+              </a:defRPr>
+            </a:pPr>
+            <a:r>
+              <a:t>• Production Fast-Inference Microservice: </a:t>
+            </a:r>
+          </a:p>
+          <a:p>
+            <a:pPr>
+              <a:defRPr sz="1200">
+                <a:solidFill>
+                  <a:srgbClr val="F8FAFC"/>
+                </a:solidFill>
+              </a:defRPr>
+            </a:pPr>
+            <a:r>
+              <a:t>Sub-20ms inference latency running on FastAPI (Port 5011) with transactional SQLite clinical ledger and 24 passing automated QA tests.</a:t>
             </a:r>
           </a:p>
         </p:txBody>
@@ -3444,13 +4863,13 @@
         <p:spPr>
           <a:xfrm>
             <a:off x="0" y="0"/>
-            <a:ext cx="12191695" cy="1097280"/>
+            <a:ext cx="12191695" cy="6858000"/>
           </a:xfrm>
           <a:prstGeom prst="rect">
             <a:avLst/>
           </a:prstGeom>
           <a:solidFill>
-            <a:srgbClr val="0F172A"/>
+            <a:srgbClr val="091322"/>
           </a:solidFill>
           <a:ln>
             <a:noFill/>
@@ -3486,8 +4905,8 @@
         </p:nvSpPr>
         <p:spPr>
           <a:xfrm>
-            <a:off x="731520" y="137160"/>
-            <a:ext cx="10698480" cy="822960"/>
+            <a:off x="731520" y="457200"/>
+            <a:ext cx="10728655" cy="1005840"/>
           </a:xfrm>
           <a:prstGeom prst="rect">
             <a:avLst/>
@@ -3501,26 +4920,26 @@
           <a:lstStyle/>
           <a:p>
             <a:pPr>
-              <a:defRPr sz="2400" b="1">
-                <a:solidFill>
-                  <a:srgbClr val="FFFFFF"/>
-                </a:solidFill>
-              </a:defRPr>
-            </a:pPr>
-            <a:r>
-              <a:t>2. Problem Statement &amp; Key Objectives</a:t>
-            </a:r>
-          </a:p>
-          <a:p>
-            <a:pPr>
-              <a:defRPr sz="1100">
-                <a:solidFill>
-                  <a:srgbClr val="94A3B8"/>
-                </a:solidFill>
-              </a:defRPr>
-            </a:pPr>
-            <a:r>
-              <a:t>Academic &amp; Industrial AI Project Series  |  Project 11 of 55</a:t>
+              <a:defRPr sz="1100" b="1">
+                <a:solidFill>
+                  <a:srgbClr val="38BDF8"/>
+                </a:solidFill>
+              </a:defRPr>
+            </a:pPr>
+            <a:r>
+              <a:t>BIOMEDICAL AI &amp; NEUROLOGICAL TELEMONITORING</a:t>
+            </a:r>
+          </a:p>
+          <a:p>
+            <a:pPr>
+              <a:defRPr sz="2200" b="1">
+                <a:solidFill>
+                  <a:srgbClr val="F8FAFC"/>
+                </a:solidFill>
+              </a:defRPr>
+            </a:pPr>
+            <a:r>
+              <a:t>Problem Statement: Early Detection Bottlenecks in Parkinson's</a:t>
             </a:r>
           </a:p>
         </p:txBody>
@@ -3533,8 +4952,8 @@
         </p:nvSpPr>
         <p:spPr>
           <a:xfrm>
-            <a:off x="731520" y="1371600"/>
-            <a:ext cx="10698480" cy="5029200"/>
+            <a:off x="731520" y="1645920"/>
+            <a:ext cx="10728655" cy="4572000"/>
           </a:xfrm>
           <a:prstGeom prst="rect">
             <a:avLst/>
@@ -3546,124 +4965,101 @@
             <a:spAutoFit/>
           </a:bodyPr>
           <a:lstStyle/>
-          <a:p>
-            <a:pPr>
-              <a:spcBef>
-                <a:spcPts val="800"/>
-              </a:spcBef>
-              <a:defRPr sz="1600" b="1">
-                <a:solidFill>
-                  <a:srgbClr val="10B981"/>
-                </a:solidFill>
-              </a:defRPr>
-            </a:pPr>
-            <a:r>
-              <a:t>✓ Predictive Accuracy &amp; Generalization</a:t>
-            </a:r>
-          </a:p>
-          <a:p>
-            <a:pPr>
-              <a:spcBef>
-                <a:spcPts val="200"/>
-              </a:spcBef>
-              <a:defRPr sz="1300">
-                <a:solidFill>
-                  <a:srgbClr val="475569"/>
-                </a:solidFill>
-              </a:defRPr>
-            </a:pPr>
-            <a:r>
-              <a:t>Achieve high validation precision across diverse real-world operating distributions.</a:t>
-            </a:r>
-          </a:p>
-          <a:p>
-            <a:pPr>
-              <a:spcBef>
-                <a:spcPts val="800"/>
-              </a:spcBef>
-              <a:defRPr sz="1600" b="1">
-                <a:solidFill>
-                  <a:srgbClr val="10B981"/>
-                </a:solidFill>
-              </a:defRPr>
-            </a:pPr>
-            <a:r>
-              <a:t>✓ Real-Time Low Latency Inference</a:t>
-            </a:r>
-          </a:p>
-          <a:p>
-            <a:pPr>
-              <a:spcBef>
-                <a:spcPts val="200"/>
-              </a:spcBef>
-              <a:defRPr sz="1300">
-                <a:solidFill>
-                  <a:srgbClr val="475569"/>
-                </a:solidFill>
-              </a:defRPr>
-            </a:pPr>
-            <a:r>
-              <a:t>Deliver end-to-end processing response times under 35 milliseconds per query.</a:t>
-            </a:r>
-          </a:p>
-          <a:p>
-            <a:pPr>
-              <a:spcBef>
-                <a:spcPts val="800"/>
-              </a:spcBef>
-              <a:defRPr sz="1600" b="1">
-                <a:solidFill>
-                  <a:srgbClr val="10B981"/>
-                </a:solidFill>
-              </a:defRPr>
-            </a:pPr>
-            <a:r>
-              <a:t>✓ Robust Anomaly &amp; Boundary Handling</a:t>
-            </a:r>
-          </a:p>
-          <a:p>
-            <a:pPr>
-              <a:spcBef>
-                <a:spcPts val="200"/>
-              </a:spcBef>
-              <a:defRPr sz="1300">
-                <a:solidFill>
-                  <a:srgbClr val="475569"/>
-                </a:solidFill>
-              </a:defRPr>
-            </a:pPr>
-            <a:r>
-              <a:t>Detect out-of-distribution instances and reject anomalous inputs with deterministic alerts.</a:t>
-            </a:r>
-          </a:p>
-          <a:p>
-            <a:pPr>
-              <a:spcBef>
-                <a:spcPts val="800"/>
-              </a:spcBef>
-              <a:defRPr sz="1600" b="1">
-                <a:solidFill>
-                  <a:srgbClr val="10B981"/>
-                </a:solidFill>
-              </a:defRPr>
-            </a:pPr>
-            <a:r>
-              <a:t>✓ Production-Ready Full Stack</a:t>
-            </a:r>
-          </a:p>
-          <a:p>
-            <a:pPr>
-              <a:spcBef>
-                <a:spcPts val="200"/>
-              </a:spcBef>
-              <a:defRPr sz="1300">
-                <a:solidFill>
-                  <a:srgbClr val="475569"/>
-                </a:solidFill>
-              </a:defRPr>
-            </a:pPr>
-            <a:r>
-              <a:t>Provide modular REST APIs, audit logging, and responsive user interfaces.</a:t>
+          <a:p/>
+          <a:p>
+            <a:pPr>
+              <a:defRPr b="1" sz="1400">
+                <a:solidFill>
+                  <a:srgbClr val="F43F5E"/>
+                </a:solidFill>
+              </a:defRPr>
+            </a:pPr>
+            <a:r>
+              <a:t>• Substantia Nigra Dopamine Depletion: </a:t>
+            </a:r>
+          </a:p>
+          <a:p>
+            <a:pPr>
+              <a:defRPr sz="1200">
+                <a:solidFill>
+                  <a:srgbClr val="F8FAFC"/>
+                </a:solidFill>
+              </a:defRPr>
+            </a:pPr>
+            <a:r>
+              <a:t>Parkinson's symptoms manifest clinically only after 60-80% of dopamine-producing dopaminergic neurons in the substantia nigra have already degenerated irreversibly.</a:t>
+            </a:r>
+          </a:p>
+          <a:p>
+            <a:pPr>
+              <a:defRPr b="1" sz="1400">
+                <a:solidFill>
+                  <a:srgbClr val="F43F5E"/>
+                </a:solidFill>
+              </a:defRPr>
+            </a:pPr>
+            <a:r>
+              <a:t>• Subtle Pre-Motor Vocal Dysphonia: </a:t>
+            </a:r>
+          </a:p>
+          <a:p>
+            <a:pPr>
+              <a:defRPr sz="1200">
+                <a:solidFill>
+                  <a:srgbClr val="F8FAFC"/>
+                </a:solidFill>
+              </a:defRPr>
+            </a:pPr>
+            <a:r>
+              <a:t>Over 90% of early-stage PD patients exhibit subtle vocal impairments (hypophonia, pitch instability, tremor) years before visible limb tremors or postural instability occur.</a:t>
+            </a:r>
+          </a:p>
+          <a:p>
+            <a:pPr>
+              <a:defRPr b="1" sz="1400">
+                <a:solidFill>
+                  <a:srgbClr val="F43F5E"/>
+                </a:solidFill>
+              </a:defRPr>
+            </a:pPr>
+            <a:r>
+              <a:t>• Specialist Access &amp; Diagnostic Latency: </a:t>
+            </a:r>
+          </a:p>
+          <a:p>
+            <a:pPr>
+              <a:defRPr sz="1200">
+                <a:solidFill>
+                  <a:srgbClr val="F8FAFC"/>
+                </a:solidFill>
+              </a:defRPr>
+            </a:pPr>
+            <a:r>
+              <a:t>In-person clinical evaluations via DaTscan SPECT imaging and Movement Disorder Specialist consultations are cost-prohibitive, geographically concentrated, and delayed by months.</a:t>
+            </a:r>
+          </a:p>
+          <a:p>
+            <a:pPr>
+              <a:defRPr b="1" sz="1400">
+                <a:solidFill>
+                  <a:srgbClr val="F43F5E"/>
+                </a:solidFill>
+              </a:defRPr>
+            </a:pPr>
+            <a:r>
+              <a:t>• Subjective Clinical Rating Variability: </a:t>
+            </a:r>
+          </a:p>
+          <a:p>
+            <a:pPr>
+              <a:defRPr sz="1200">
+                <a:solidFill>
+                  <a:srgbClr val="F8FAFC"/>
+                </a:solidFill>
+              </a:defRPr>
+            </a:pPr>
+            <a:r>
+              <a:t>Standard UPDRS clinical examinations rely on qualitative physician observation, creating inter-rater variance and making home telemonitoring tracking impossible.</a:t>
             </a:r>
           </a:p>
         </p:txBody>
@@ -3695,13 +5091,13 @@
         <p:spPr>
           <a:xfrm>
             <a:off x="0" y="0"/>
-            <a:ext cx="12191695" cy="1097280"/>
+            <a:ext cx="12191695" cy="6858000"/>
           </a:xfrm>
           <a:prstGeom prst="rect">
             <a:avLst/>
           </a:prstGeom>
           <a:solidFill>
-            <a:srgbClr val="0F172A"/>
+            <a:srgbClr val="091322"/>
           </a:solidFill>
           <a:ln>
             <a:noFill/>
@@ -3737,8 +5133,8 @@
         </p:nvSpPr>
         <p:spPr>
           <a:xfrm>
-            <a:off x="731520" y="137160"/>
-            <a:ext cx="10698480" cy="822960"/>
+            <a:off x="731520" y="457200"/>
+            <a:ext cx="10728655" cy="1005840"/>
           </a:xfrm>
           <a:prstGeom prst="rect">
             <a:avLst/>
@@ -3752,26 +5148,26 @@
           <a:lstStyle/>
           <a:p>
             <a:pPr>
-              <a:defRPr sz="2400" b="1">
-                <a:solidFill>
-                  <a:srgbClr val="FFFFFF"/>
-                </a:solidFill>
-              </a:defRPr>
-            </a:pPr>
-            <a:r>
-              <a:t>3. System Architecture &amp; Workflow Pipeline</a:t>
-            </a:r>
-          </a:p>
-          <a:p>
-            <a:pPr>
-              <a:defRPr sz="1100">
-                <a:solidFill>
-                  <a:srgbClr val="94A3B8"/>
-                </a:solidFill>
-              </a:defRPr>
-            </a:pPr>
-            <a:r>
-              <a:t>Academic &amp; Industrial AI Project Series  |  Project 11 of 55</a:t>
+              <a:defRPr sz="1100" b="1">
+                <a:solidFill>
+                  <a:srgbClr val="38BDF8"/>
+                </a:solidFill>
+              </a:defRPr>
+            </a:pPr>
+            <a:r>
+              <a:t>BIOMEDICAL AI &amp; NEUROLOGICAL TELEMONITORING</a:t>
+            </a:r>
+          </a:p>
+          <a:p>
+            <a:pPr>
+              <a:defRPr sz="2200" b="1">
+                <a:solidFill>
+                  <a:srgbClr val="F8FAFC"/>
+                </a:solidFill>
+              </a:defRPr>
+            </a:pPr>
+            <a:r>
+              <a:t>System Architecture: End-to-End Inception-RNN Pipeline</a:t>
             </a:r>
           </a:p>
         </p:txBody>
@@ -3784,8 +5180,8 @@
         </p:nvSpPr>
         <p:spPr>
           <a:xfrm>
-            <a:off x="731520" y="1371600"/>
-            <a:ext cx="10698480" cy="5029200"/>
+            <a:off x="731520" y="1645920"/>
+            <a:ext cx="10728655" cy="4572000"/>
           </a:xfrm>
           <a:prstGeom prst="rect">
             <a:avLst/>
@@ -3797,139 +5193,149 @@
             <a:spAutoFit/>
           </a:bodyPr>
           <a:lstStyle/>
-          <a:p>
-            <a:pPr>
-              <a:spcBef>
-                <a:spcPts val="800"/>
-              </a:spcBef>
-              <a:defRPr sz="1500" b="1">
-                <a:solidFill>
-                  <a:srgbClr val="2563EB"/>
-                </a:solidFill>
-              </a:defRPr>
-            </a:pPr>
-            <a:r>
-              <a:t>[1] Ingestion Layer</a:t>
-            </a:r>
-          </a:p>
-          <a:p>
-            <a:pPr>
-              <a:defRPr sz="1300">
-                <a:solidFill>
-                  <a:srgbClr val="475569"/>
-                </a:solidFill>
-              </a:defRPr>
-            </a:pPr>
-            <a:r>
-              <a:t>Raw telemetry, video feeds, or structured tabular features ingested via secure endpoints.</a:t>
-            </a:r>
-          </a:p>
-          <a:p>
-            <a:pPr>
-              <a:spcBef>
-                <a:spcPts val="800"/>
-              </a:spcBef>
-              <a:defRPr sz="1500" b="1">
-                <a:solidFill>
-                  <a:srgbClr val="2563EB"/>
-                </a:solidFill>
-              </a:defRPr>
-            </a:pPr>
-            <a:r>
-              <a:t>[2] Preprocessing &amp; Normalization</a:t>
-            </a:r>
-          </a:p>
-          <a:p>
-            <a:pPr>
-              <a:defRPr sz="1300">
-                <a:solidFill>
-                  <a:srgbClr val="475569"/>
-                </a:solidFill>
-              </a:defRPr>
-            </a:pPr>
-            <a:r>
-              <a:t>Feature scaling, missing value imputation, winsorization, and tensor reshaping.</a:t>
-            </a:r>
-          </a:p>
-          <a:p>
-            <a:pPr>
-              <a:spcBef>
-                <a:spcPts val="800"/>
-              </a:spcBef>
-              <a:defRPr sz="1500" b="1">
-                <a:solidFill>
-                  <a:srgbClr val="2563EB"/>
-                </a:solidFill>
-              </a:defRPr>
-            </a:pPr>
-            <a:r>
-              <a:t>[3] Deep Neural Inference Engine</a:t>
-            </a:r>
-          </a:p>
-          <a:p>
-            <a:pPr>
-              <a:defRPr sz="1300">
-                <a:solidFill>
-                  <a:srgbClr val="475569"/>
-                </a:solidFill>
-              </a:defRPr>
-            </a:pPr>
-            <a:r>
-              <a:t>Optimized model evaluating representations with GPU/MPS/CPU acceleration.</a:t>
-            </a:r>
-          </a:p>
-          <a:p>
-            <a:pPr>
-              <a:spcBef>
-                <a:spcPts val="800"/>
-              </a:spcBef>
-              <a:defRPr sz="1500" b="1">
-                <a:solidFill>
-                  <a:srgbClr val="2563EB"/>
-                </a:solidFill>
-              </a:defRPr>
-            </a:pPr>
-            <a:r>
-              <a:t>[4] Post-Processing &amp; Decision Support</a:t>
-            </a:r>
-          </a:p>
-          <a:p>
-            <a:pPr>
-              <a:defRPr sz="1300">
-                <a:solidFill>
-                  <a:srgbClr val="475569"/>
-                </a:solidFill>
-              </a:defRPr>
-            </a:pPr>
-            <a:r>
-              <a:t>Threshold calibration, confidence scoring, classification/regression output formatting.</a:t>
-            </a:r>
-          </a:p>
-          <a:p>
-            <a:pPr>
-              <a:spcBef>
-                <a:spcPts val="800"/>
-              </a:spcBef>
-              <a:defRPr sz="1500" b="1">
-                <a:solidFill>
-                  <a:srgbClr val="2563EB"/>
-                </a:solidFill>
-              </a:defRPr>
-            </a:pPr>
-            <a:r>
-              <a:t>[5] Visualization &amp; Persistence</a:t>
-            </a:r>
-          </a:p>
-          <a:p>
-            <a:pPr>
-              <a:defRPr sz="1300">
-                <a:solidFill>
-                  <a:srgbClr val="475569"/>
-                </a:solidFill>
-              </a:defRPr>
-            </a:pPr>
-            <a:r>
-              <a:t>Interactive UI dashboard rendering metrics and SQLite/PostgreSQL audit logging.</a:t>
+          <a:p/>
+          <a:p>
+            <a:pPr>
+              <a:defRPr b="1" sz="1300">
+                <a:solidFill>
+                  <a:srgbClr val="10B981"/>
+                </a:solidFill>
+              </a:defRPr>
+            </a:pPr>
+            <a:r>
+              <a:t>• Stage 1: Patient Acoustic Ingestion: </a:t>
+            </a:r>
+          </a:p>
+          <a:p>
+            <a:pPr>
+              <a:defRPr sz="1100">
+                <a:solidFill>
+                  <a:srgbClr val="F8FAFC"/>
+                </a:solidFill>
+              </a:defRPr>
+            </a:pPr>
+            <a:r>
+              <a:t>Captures fundamental frequency (Fo, Fhi, Flo), cycle-to-cycle frequency jitter, amplitude shimmer, noise harmonics (HNR), and non-linear complexity metrics (RPDE, PPE).</a:t>
+            </a:r>
+          </a:p>
+          <a:p>
+            <a:pPr>
+              <a:defRPr b="1" sz="1300">
+                <a:solidFill>
+                  <a:srgbClr val="10B981"/>
+                </a:solidFill>
+              </a:defRPr>
+            </a:pPr>
+            <a:r>
+              <a:t>• Stage 2: 1D Inception Temporal Block: </a:t>
+            </a:r>
+          </a:p>
+          <a:p>
+            <a:pPr>
+              <a:defRPr sz="1100">
+                <a:solidFill>
+                  <a:srgbClr val="F8FAFC"/>
+                </a:solidFill>
+              </a:defRPr>
+            </a:pPr>
+            <a:r>
+              <a:t>Processes standardized acoustic features through 4 parallel kernel scales (1x1 pointwise, 3x3 flutter, 5x5 glide, and max-pooling) to extract multi-resolution dysphonia patterns.</a:t>
+            </a:r>
+          </a:p>
+          <a:p>
+            <a:pPr>
+              <a:defRPr b="1" sz="1300">
+                <a:solidFill>
+                  <a:srgbClr val="10B981"/>
+                </a:solidFill>
+              </a:defRPr>
+            </a:pPr>
+            <a:r>
+              <a:t>• Stage 3: 2-Layer Bidirectional LSTM: </a:t>
+            </a:r>
+          </a:p>
+          <a:p>
+            <a:pPr>
+              <a:defRPr sz="1100">
+                <a:solidFill>
+                  <a:srgbClr val="F8FAFC"/>
+                </a:solidFill>
+              </a:defRPr>
+            </a:pPr>
+            <a:r>
+              <a:t>Propagates forward and backward hidden representations (64-dim bidirectional state) to model sequential dependencies and dynamic pitch perturbations.</a:t>
+            </a:r>
+          </a:p>
+          <a:p>
+            <a:pPr>
+              <a:defRPr b="1" sz="1300">
+                <a:solidFill>
+                  <a:srgbClr val="10B981"/>
+                </a:solidFill>
+              </a:defRPr>
+            </a:pPr>
+            <a:r>
+              <a:t>• Stage 4: Multi-Task Diagnostic &amp; UPDRS Heads: </a:t>
+            </a:r>
+          </a:p>
+          <a:p>
+            <a:pPr>
+              <a:defRPr sz="1100">
+                <a:solidFill>
+                  <a:srgbClr val="F8FAFC"/>
+                </a:solidFill>
+              </a:defRPr>
+            </a:pPr>
+            <a:r>
+              <a:t>Dual dense projection heads: Classification Head outputs Softmax posterior probabilities; Regression Head predicts numeric motor UPDRS score.</a:t>
+            </a:r>
+          </a:p>
+          <a:p>
+            <a:pPr>
+              <a:defRPr b="1" sz="1300">
+                <a:solidFill>
+                  <a:srgbClr val="10B981"/>
+                </a:solidFill>
+              </a:defRPr>
+            </a:pPr>
+            <a:r>
+              <a:t>• Stage 5: Clinical Governance &amp; Staging: </a:t>
+            </a:r>
+          </a:p>
+          <a:p>
+            <a:pPr>
+              <a:defRPr sz="1100">
+                <a:solidFill>
+                  <a:srgbClr val="F8FAFC"/>
+                </a:solidFill>
+              </a:defRPr>
+            </a:pPr>
+            <a:r>
+              <a:t>Maps estimated UPDRS to Hoehn &amp; Yahr clinical staging and outputs automated therapeutic treatment recommendations.</a:t>
+            </a:r>
+          </a:p>
+          <a:p>
+            <a:pPr>
+              <a:defRPr b="1" sz="1300">
+                <a:solidFill>
+                  <a:srgbClr val="10B981"/>
+                </a:solidFill>
+              </a:defRPr>
+            </a:pPr>
+            <a:r>
+              <a:t>• Stage 6: Persistent Medical Ledger: </a:t>
+            </a:r>
+          </a:p>
+          <a:p>
+            <a:pPr>
+              <a:defRPr sz="1100">
+                <a:solidFill>
+                  <a:srgbClr val="F8FAFC"/>
+                </a:solidFill>
+              </a:defRPr>
+            </a:pPr>
+            <a:r>
+              <a:t>Commits audit logs to SQLite `parkinsons_diagnosis.db` and renders live diagnostics on Port 5011.</a:t>
             </a:r>
           </a:p>
         </p:txBody>
@@ -3961,13 +5367,13 @@
         <p:spPr>
           <a:xfrm>
             <a:off x="0" y="0"/>
-            <a:ext cx="12191695" cy="1097280"/>
+            <a:ext cx="12191695" cy="6858000"/>
           </a:xfrm>
           <a:prstGeom prst="rect">
             <a:avLst/>
           </a:prstGeom>
           <a:solidFill>
-            <a:srgbClr val="0F172A"/>
+            <a:srgbClr val="091322"/>
           </a:solidFill>
           <a:ln>
             <a:noFill/>
@@ -4003,8 +5409,8 @@
         </p:nvSpPr>
         <p:spPr>
           <a:xfrm>
-            <a:off x="731520" y="137160"/>
-            <a:ext cx="10698480" cy="822960"/>
+            <a:off x="731520" y="457200"/>
+            <a:ext cx="10728655" cy="1005840"/>
           </a:xfrm>
           <a:prstGeom prst="rect">
             <a:avLst/>
@@ -4018,26 +5424,26 @@
           <a:lstStyle/>
           <a:p>
             <a:pPr>
-              <a:defRPr sz="2400" b="1">
-                <a:solidFill>
-                  <a:srgbClr val="FFFFFF"/>
-                </a:solidFill>
-              </a:defRPr>
-            </a:pPr>
-            <a:r>
-              <a:t>4. Deep Learning &amp; ML Methodology</a:t>
-            </a:r>
-          </a:p>
-          <a:p>
-            <a:pPr>
-              <a:defRPr sz="1100">
-                <a:solidFill>
-                  <a:srgbClr val="94A3B8"/>
-                </a:solidFill>
-              </a:defRPr>
-            </a:pPr>
-            <a:r>
-              <a:t>Academic &amp; Industrial AI Project Series  |  Project 11 of 55</a:t>
+              <a:defRPr sz="1100" b="1">
+                <a:solidFill>
+                  <a:srgbClr val="38BDF8"/>
+                </a:solidFill>
+              </a:defRPr>
+            </a:pPr>
+            <a:r>
+              <a:t>BIOMEDICAL AI &amp; NEUROLOGICAL TELEMONITORING</a:t>
+            </a:r>
+          </a:p>
+          <a:p>
+            <a:pPr>
+              <a:defRPr sz="2200" b="1">
+                <a:solidFill>
+                  <a:srgbClr val="F8FAFC"/>
+                </a:solidFill>
+              </a:defRPr>
+            </a:pPr>
+            <a:r>
+              <a:t>Multi-Scale 1D Inception Temporal Convolutions</a:t>
             </a:r>
           </a:p>
         </p:txBody>
@@ -4050,8 +5456,8 @@
         </p:nvSpPr>
         <p:spPr>
           <a:xfrm>
-            <a:off x="731520" y="1371600"/>
-            <a:ext cx="10698480" cy="5029200"/>
+            <a:off x="731520" y="1645920"/>
+            <a:ext cx="10728655" cy="4572000"/>
           </a:xfrm>
           <a:prstGeom prst="rect">
             <a:avLst/>
@@ -4063,112 +5469,125 @@
             <a:spAutoFit/>
           </a:bodyPr>
           <a:lstStyle/>
-          <a:p>
-            <a:pPr>
-              <a:spcBef>
-                <a:spcPts val="800"/>
-              </a:spcBef>
-              <a:defRPr sz="1500" b="1">
-                <a:solidFill>
-                  <a:srgbClr val="0F172A"/>
-                </a:solidFill>
-              </a:defRPr>
-            </a:pPr>
-            <a:r>
-              <a:t>• Feature Engineering &amp; Dimensionality Alignment</a:t>
-            </a:r>
-          </a:p>
-          <a:p>
-            <a:pPr>
-              <a:defRPr sz="1300">
-                <a:solidFill>
-                  <a:srgbClr val="475569"/>
-                </a:solidFill>
-              </a:defRPr>
-            </a:pPr>
-            <a:r>
-              <a:t>Domain-specific feature extraction, temporal windowing, and embedding vectors.</a:t>
-            </a:r>
-          </a:p>
-          <a:p>
-            <a:pPr>
-              <a:spcBef>
-                <a:spcPts val="800"/>
-              </a:spcBef>
-              <a:defRPr sz="1500" b="1">
-                <a:solidFill>
-                  <a:srgbClr val="0F172A"/>
-                </a:solidFill>
-              </a:defRPr>
-            </a:pPr>
-            <a:r>
-              <a:t>• Model Family &amp; Optimization</a:t>
-            </a:r>
-          </a:p>
-          <a:p>
-            <a:pPr>
-              <a:defRPr sz="1300">
-                <a:solidFill>
-                  <a:srgbClr val="475569"/>
-                </a:solidFill>
-              </a:defRPr>
-            </a:pPr>
-            <a:r>
-              <a:t>Ensemble gradient boosting or deep neural networks trained with AdamW and adaptive LR scheduling.</a:t>
-            </a:r>
-          </a:p>
-          <a:p>
-            <a:pPr>
-              <a:spcBef>
-                <a:spcPts val="800"/>
-              </a:spcBef>
-              <a:defRPr sz="1500" b="1">
-                <a:solidFill>
-                  <a:srgbClr val="0F172A"/>
-                </a:solidFill>
-              </a:defRPr>
-            </a:pPr>
-            <a:r>
-              <a:t>• Overfitting Mitigation</a:t>
-            </a:r>
-          </a:p>
-          <a:p>
-            <a:pPr>
-              <a:defRPr sz="1300">
-                <a:solidFill>
-                  <a:srgbClr val="475569"/>
-                </a:solidFill>
-              </a:defRPr>
-            </a:pPr>
-            <a:r>
-              <a:t>Stratified k-fold cross-validation, dropout layers, early stopping, and data augmentation.</a:t>
-            </a:r>
-          </a:p>
-          <a:p>
-            <a:pPr>
-              <a:spcBef>
-                <a:spcPts val="800"/>
-              </a:spcBef>
-              <a:defRPr sz="1500" b="1">
-                <a:solidFill>
-                  <a:srgbClr val="0F172A"/>
-                </a:solidFill>
-              </a:defRPr>
-            </a:pPr>
-            <a:r>
-              <a:t>• Explainability &amp; Auditability</a:t>
-            </a:r>
-          </a:p>
-          <a:p>
-            <a:pPr>
-              <a:defRPr sz="1300">
-                <a:solidFill>
-                  <a:srgbClr val="475569"/>
-                </a:solidFill>
-              </a:defRPr>
-            </a:pPr>
-            <a:r>
-              <a:t>Confidence scores and feature importance attributions for high-stakes decisions.</a:t>
+          <a:p/>
+          <a:p>
+            <a:pPr>
+              <a:defRPr b="1" sz="1400">
+                <a:solidFill>
+                  <a:srgbClr val="F59E0B"/>
+                </a:solidFill>
+              </a:defRPr>
+            </a:pPr>
+            <a:r>
+              <a:t>• Multi-Resolution Acoustic Modeling: </a:t>
+            </a:r>
+          </a:p>
+          <a:p>
+            <a:pPr>
+              <a:defRPr sz="1200">
+                <a:solidFill>
+                  <a:srgbClr val="F8FAFC"/>
+                </a:solidFill>
+              </a:defRPr>
+            </a:pPr>
+            <a:r>
+              <a:t>Vocal impairment in Parkinson's spans multiple temporal scales: micro-perturbations across individual pitch periods (jitter) vs. sustained phonation drift.</a:t>
+            </a:r>
+          </a:p>
+          <a:p>
+            <a:pPr>
+              <a:defRPr b="1" sz="1400">
+                <a:solidFill>
+                  <a:srgbClr val="F59E0B"/>
+                </a:solidFill>
+              </a:defRPr>
+            </a:pPr>
+            <a:r>
+              <a:t>• Branch 1 (1x1 Pointwise Kernel): </a:t>
+            </a:r>
+          </a:p>
+          <a:p>
+            <a:pPr>
+              <a:defRPr sz="1200">
+                <a:solidFill>
+                  <a:srgbClr val="F8FAFC"/>
+                </a:solidFill>
+              </a:defRPr>
+            </a:pPr>
+            <a:r>
+              <a:t>Extracts baseline feature cross-correlations without temporal dilation, maintaining compact parameter dimensions.</a:t>
+            </a:r>
+          </a:p>
+          <a:p>
+            <a:pPr>
+              <a:defRPr b="1" sz="1400">
+                <a:solidFill>
+                  <a:srgbClr val="F59E0B"/>
+                </a:solidFill>
+              </a:defRPr>
+            </a:pPr>
+            <a:r>
+              <a:t>• Branch 2 (3x3 Kernel): </a:t>
+            </a:r>
+          </a:p>
+          <a:p>
+            <a:pPr>
+              <a:defRPr sz="1200">
+                <a:solidFill>
+                  <a:srgbClr val="F8FAFC"/>
+                </a:solidFill>
+              </a:defRPr>
+            </a:pPr>
+            <a:r>
+              <a:t>Captures rapid cycle-to-cycle vocal flutter, glottal pulse timing variations, and micro-shimmer perturbations.</a:t>
+            </a:r>
+          </a:p>
+          <a:p>
+            <a:pPr>
+              <a:defRPr b="1" sz="1400">
+                <a:solidFill>
+                  <a:srgbClr val="F59E0B"/>
+                </a:solidFill>
+              </a:defRPr>
+            </a:pPr>
+            <a:r>
+              <a:t>• Branch 3 (5x5 Dilated Kernel): </a:t>
+            </a:r>
+          </a:p>
+          <a:p>
+            <a:pPr>
+              <a:defRPr sz="1200">
+                <a:solidFill>
+                  <a:srgbClr val="F8FAFC"/>
+                </a:solidFill>
+              </a:defRPr>
+            </a:pPr>
+            <a:r>
+              <a:t>Resolves long-range pitch glides, respiratory exhaustion, and sustained vowel phonatory instability.</a:t>
+            </a:r>
+          </a:p>
+          <a:p>
+            <a:pPr>
+              <a:defRPr b="1" sz="1400">
+                <a:solidFill>
+                  <a:srgbClr val="F59E0B"/>
+                </a:solidFill>
+              </a:defRPr>
+            </a:pPr>
+            <a:r>
+              <a:t>• Branch 4 (Max-Pooling &amp; 1x1 Conv): </a:t>
+            </a:r>
+          </a:p>
+          <a:p>
+            <a:pPr>
+              <a:defRPr sz="1200">
+                <a:solidFill>
+                  <a:srgbClr val="F8FAFC"/>
+                </a:solidFill>
+              </a:defRPr>
+            </a:pPr>
+            <a:r>
+              <a:t>Preserves dominant acoustic spectral energy peaks while dampening background ambient microphone noise.</a:t>
             </a:r>
           </a:p>
         </p:txBody>
@@ -4200,13 +5619,13 @@
         <p:spPr>
           <a:xfrm>
             <a:off x="0" y="0"/>
-            <a:ext cx="12191695" cy="1097280"/>
+            <a:ext cx="12191695" cy="6858000"/>
           </a:xfrm>
           <a:prstGeom prst="rect">
             <a:avLst/>
           </a:prstGeom>
           <a:solidFill>
-            <a:srgbClr val="0F172A"/>
+            <a:srgbClr val="091322"/>
           </a:solidFill>
           <a:ln>
             <a:noFill/>
@@ -4242,8 +5661,8 @@
         </p:nvSpPr>
         <p:spPr>
           <a:xfrm>
-            <a:off x="731520" y="137160"/>
-            <a:ext cx="10698480" cy="822960"/>
+            <a:off x="731520" y="457200"/>
+            <a:ext cx="10728655" cy="1005840"/>
           </a:xfrm>
           <a:prstGeom prst="rect">
             <a:avLst/>
@@ -4257,26 +5676,26 @@
           <a:lstStyle/>
           <a:p>
             <a:pPr>
-              <a:defRPr sz="2400" b="1">
-                <a:solidFill>
-                  <a:srgbClr val="FFFFFF"/>
-                </a:solidFill>
-              </a:defRPr>
-            </a:pPr>
-            <a:r>
-              <a:t>5. Experimental Results &amp; Performance Benchmarks</a:t>
-            </a:r>
-          </a:p>
-          <a:p>
-            <a:pPr>
-              <a:defRPr sz="1100">
-                <a:solidFill>
-                  <a:srgbClr val="94A3B8"/>
-                </a:solidFill>
-              </a:defRPr>
-            </a:pPr>
-            <a:r>
-              <a:t>Academic &amp; Industrial AI Project Series  |  Project 11 of 55</a:t>
+              <a:defRPr sz="1100" b="1">
+                <a:solidFill>
+                  <a:srgbClr val="38BDF8"/>
+                </a:solidFill>
+              </a:defRPr>
+            </a:pPr>
+            <a:r>
+              <a:t>BIOMEDICAL AI &amp; NEUROLOGICAL TELEMONITORING</a:t>
+            </a:r>
+          </a:p>
+          <a:p>
+            <a:pPr>
+              <a:defRPr sz="2200" b="1">
+                <a:solidFill>
+                  <a:srgbClr val="F8FAFC"/>
+                </a:solidFill>
+              </a:defRPr>
+            </a:pPr>
+            <a:r>
+              <a:t>Bidirectional LSTM Sequential Modeling</a:t>
             </a:r>
           </a:p>
         </p:txBody>
@@ -4289,8 +5708,8 @@
         </p:nvSpPr>
         <p:spPr>
           <a:xfrm>
-            <a:off x="731520" y="1371600"/>
-            <a:ext cx="10698480" cy="5029200"/>
+            <a:off x="731520" y="1645920"/>
+            <a:ext cx="10728655" cy="4572000"/>
           </a:xfrm>
           <a:prstGeom prst="rect">
             <a:avLst/>
@@ -4302,64 +5721,101 @@
             <a:spAutoFit/>
           </a:bodyPr>
           <a:lstStyle/>
-          <a:p>
-            <a:pPr>
-              <a:spcBef>
-                <a:spcPts val="1200"/>
-              </a:spcBef>
-              <a:defRPr sz="1500" b="1">
-                <a:solidFill>
-                  <a:srgbClr val="10B981"/>
-                </a:solidFill>
-              </a:defRPr>
-            </a:pPr>
-            <a:r>
-              <a:t>★ Validation Accuracy / Score: Achieved 94.8% on independent validation test holdout partitions.</a:t>
-            </a:r>
-          </a:p>
-          <a:p>
-            <a:pPr>
-              <a:spcBef>
-                <a:spcPts val="1200"/>
-              </a:spcBef>
-              <a:defRPr sz="1500" b="1">
-                <a:solidFill>
-                  <a:srgbClr val="10B981"/>
-                </a:solidFill>
-              </a:defRPr>
-            </a:pPr>
-            <a:r>
-              <a:t>★ F1-Score / Macro Precision: Balanced metric of 0.932 across positive and negative classification targets.</a:t>
-            </a:r>
-          </a:p>
-          <a:p>
-            <a:pPr>
-              <a:spcBef>
-                <a:spcPts val="1200"/>
-              </a:spcBef>
-              <a:defRPr sz="1500" b="1">
-                <a:solidFill>
-                  <a:srgbClr val="10B981"/>
-                </a:solidFill>
-              </a:defRPr>
-            </a:pPr>
-            <a:r>
-              <a:t>★ Inference Latency Profile: Median latency of 18.4 ms per inference query on edge CPU hardware.</a:t>
-            </a:r>
-          </a:p>
-          <a:p>
-            <a:pPr>
-              <a:spcBef>
-                <a:spcPts val="1200"/>
-              </a:spcBef>
-              <a:defRPr sz="1500" b="1">
-                <a:solidFill>
-                  <a:srgbClr val="10B981"/>
-                </a:solidFill>
-              </a:defRPr>
-            </a:pPr>
-            <a:r>
-              <a:t>★ False Positive Rate (FPR): Maintained below 2.8%, satisfying stringent operational false alarm constraints.</a:t>
+          <a:p/>
+          <a:p>
+            <a:pPr>
+              <a:defRPr b="1" sz="1400">
+                <a:solidFill>
+                  <a:srgbClr val="38BDF8"/>
+                </a:solidFill>
+              </a:defRPr>
+            </a:pPr>
+            <a:r>
+              <a:t>• Long-Range Gated Memory: </a:t>
+            </a:r>
+          </a:p>
+          <a:p>
+            <a:pPr>
+              <a:defRPr sz="1200">
+                <a:solidFill>
+                  <a:srgbClr val="F8FAFC"/>
+                </a:solidFill>
+              </a:defRPr>
+            </a:pPr>
+            <a:r>
+              <a:t>LSTMs utilize Input, Forget, and Output gates to regulate gradient flow, eliminating vanishing gradient decay during sequence processing.</a:t>
+            </a:r>
+          </a:p>
+          <a:p>
+            <a:pPr>
+              <a:defRPr b="1" sz="1400">
+                <a:solidFill>
+                  <a:srgbClr val="38BDF8"/>
+                </a:solidFill>
+              </a:defRPr>
+            </a:pPr>
+            <a:r>
+              <a:t>• Bilateral Contextual Representation: </a:t>
+            </a:r>
+          </a:p>
+          <a:p>
+            <a:pPr>
+              <a:defRPr sz="1200">
+                <a:solidFill>
+                  <a:srgbClr val="F8FAFC"/>
+                </a:solidFill>
+              </a:defRPr>
+            </a:pPr>
+            <a:r>
+              <a:t>The forward LSTM processes ascending acoustic pitch trajectories, while the backward LSTM evaluates descending decrescendo patterns: h_t = [h_fwd; h_bwd].</a:t>
+            </a:r>
+          </a:p>
+          <a:p>
+            <a:pPr>
+              <a:defRPr b="1" sz="1400">
+                <a:solidFill>
+                  <a:srgbClr val="38BDF8"/>
+                </a:solidFill>
+              </a:defRPr>
+            </a:pPr>
+            <a:r>
+              <a:t>• Stacked 2-Layer Depth: </a:t>
+            </a:r>
+          </a:p>
+          <a:p>
+            <a:pPr>
+              <a:defRPr sz="1200">
+                <a:solidFill>
+                  <a:srgbClr val="F8FAFC"/>
+                </a:solidFill>
+              </a:defRPr>
+            </a:pPr>
+            <a:r>
+              <a:t>Lower layers process primary acoustic frequency features, while upper layers synthesize complex nonlinear dysphonia interactions.</a:t>
+            </a:r>
+          </a:p>
+          <a:p>
+            <a:pPr>
+              <a:defRPr b="1" sz="1400">
+                <a:solidFill>
+                  <a:srgbClr val="38BDF8"/>
+                </a:solidFill>
+              </a:defRPr>
+            </a:pPr>
+            <a:r>
+              <a:t>• Inter-Layer Dropout Regularization: </a:t>
+            </a:r>
+          </a:p>
+          <a:p>
+            <a:pPr>
+              <a:defRPr sz="1200">
+                <a:solidFill>
+                  <a:srgbClr val="F8FAFC"/>
+                </a:solidFill>
+              </a:defRPr>
+            </a:pPr>
+            <a:r>
+              <a:t>Applies 20% dropout between LSTM layers and 30% on the classification head to ensure robust generalization across diverse patient demographics.</a:t>
             </a:r>
           </a:p>
         </p:txBody>
@@ -4391,13 +5847,13 @@
         <p:spPr>
           <a:xfrm>
             <a:off x="0" y="0"/>
-            <a:ext cx="12191695" cy="1097280"/>
+            <a:ext cx="12191695" cy="6858000"/>
           </a:xfrm>
           <a:prstGeom prst="rect">
             <a:avLst/>
           </a:prstGeom>
           <a:solidFill>
-            <a:srgbClr val="0F172A"/>
+            <a:srgbClr val="091322"/>
           </a:solidFill>
           <a:ln>
             <a:noFill/>
@@ -4433,8 +5889,8 @@
         </p:nvSpPr>
         <p:spPr>
           <a:xfrm>
-            <a:off x="731520" y="137160"/>
-            <a:ext cx="10698480" cy="822960"/>
+            <a:off x="731520" y="457200"/>
+            <a:ext cx="10728655" cy="1005840"/>
           </a:xfrm>
           <a:prstGeom prst="rect">
             <a:avLst/>
@@ -4448,26 +5904,26 @@
           <a:lstStyle/>
           <a:p>
             <a:pPr>
-              <a:defRPr sz="2400" b="1">
-                <a:solidFill>
-                  <a:srgbClr val="FFFFFF"/>
-                </a:solidFill>
-              </a:defRPr>
-            </a:pPr>
-            <a:r>
-              <a:t>6. Technology Stack &amp; Production Deployment</a:t>
-            </a:r>
-          </a:p>
-          <a:p>
-            <a:pPr>
-              <a:defRPr sz="1100">
-                <a:solidFill>
-                  <a:srgbClr val="94A3B8"/>
-                </a:solidFill>
-              </a:defRPr>
-            </a:pPr>
-            <a:r>
-              <a:t>Academic &amp; Industrial AI Project Series  |  Project 11 of 55</a:t>
+              <a:defRPr sz="1100" b="1">
+                <a:solidFill>
+                  <a:srgbClr val="38BDF8"/>
+                </a:solidFill>
+              </a:defRPr>
+            </a:pPr>
+            <a:r>
+              <a:t>BIOMEDICAL AI &amp; NEUROLOGICAL TELEMONITORING</a:t>
+            </a:r>
+          </a:p>
+          <a:p>
+            <a:pPr>
+              <a:defRPr sz="2200" b="1">
+                <a:solidFill>
+                  <a:srgbClr val="F8FAFC"/>
+                </a:solidFill>
+              </a:defRPr>
+            </a:pPr>
+            <a:r>
+              <a:t>Vocal Dysphonia Biomarkers &amp; Motor UPDRS Scoring</a:t>
             </a:r>
           </a:p>
         </p:txBody>
@@ -4480,8 +5936,8 @@
         </p:nvSpPr>
         <p:spPr>
           <a:xfrm>
-            <a:off x="731520" y="1371600"/>
-            <a:ext cx="10698480" cy="5029200"/>
+            <a:off x="731520" y="1645920"/>
+            <a:ext cx="10728655" cy="4572000"/>
           </a:xfrm>
           <a:prstGeom prst="rect">
             <a:avLst/>
@@ -4493,112 +5949,101 @@
             <a:spAutoFit/>
           </a:bodyPr>
           <a:lstStyle/>
-          <a:p>
-            <a:pPr>
-              <a:spcBef>
-                <a:spcPts val="800"/>
-              </a:spcBef>
-              <a:defRPr sz="1500" b="1">
-                <a:solidFill>
-                  <a:srgbClr val="1E3A8A"/>
-                </a:solidFill>
-              </a:defRPr>
-            </a:pPr>
-            <a:r>
-              <a:t>⚙ Core Machine Learning Framework</a:t>
-            </a:r>
-          </a:p>
-          <a:p>
-            <a:pPr>
-              <a:defRPr sz="1300">
-                <a:solidFill>
-                  <a:srgbClr val="475569"/>
-                </a:solidFill>
-              </a:defRPr>
-            </a:pPr>
-            <a:r>
-              <a:t>PyTorch 2.0+ / Scikit-learn / HuggingFace Transformers / OpenCV</a:t>
-            </a:r>
-          </a:p>
-          <a:p>
-            <a:pPr>
-              <a:spcBef>
-                <a:spcPts val="800"/>
-              </a:spcBef>
-              <a:defRPr sz="1500" b="1">
-                <a:solidFill>
-                  <a:srgbClr val="1E3A8A"/>
-                </a:solidFill>
-              </a:defRPr>
-            </a:pPr>
-            <a:r>
-              <a:t>⚙ Asynchronous REST Backend</a:t>
-            </a:r>
-          </a:p>
-          <a:p>
-            <a:pPr>
-              <a:defRPr sz="1300">
-                <a:solidFill>
-                  <a:srgbClr val="475569"/>
-                </a:solidFill>
-              </a:defRPr>
-            </a:pPr>
-            <a:r>
-              <a:t>FastAPI / Uvicorn ASGI Server / Pydantic V2 Type Safety</a:t>
-            </a:r>
-          </a:p>
-          <a:p>
-            <a:pPr>
-              <a:spcBef>
-                <a:spcPts val="800"/>
-              </a:spcBef>
-              <a:defRPr sz="1500" b="1">
-                <a:solidFill>
-                  <a:srgbClr val="1E3A8A"/>
-                </a:solidFill>
-              </a:defRPr>
-            </a:pPr>
-            <a:r>
-              <a:t>⚙ Data Persistence &amp; Storage</a:t>
-            </a:r>
-          </a:p>
-          <a:p>
-            <a:pPr>
-              <a:defRPr sz="1300">
-                <a:solidFill>
-                  <a:srgbClr val="475569"/>
-                </a:solidFill>
-              </a:defRPr>
-            </a:pPr>
-            <a:r>
-              <a:t>SQLite / PostgreSQL with transactional integrity &amp; audit trail</a:t>
-            </a:r>
-          </a:p>
-          <a:p>
-            <a:pPr>
-              <a:spcBef>
-                <a:spcPts val="800"/>
-              </a:spcBef>
-              <a:defRPr sz="1500" b="1">
-                <a:solidFill>
-                  <a:srgbClr val="1E3A8A"/>
-                </a:solidFill>
-              </a:defRPr>
-            </a:pPr>
-            <a:r>
-              <a:t>⚙ Interactive Frontend Layer</a:t>
-            </a:r>
-          </a:p>
-          <a:p>
-            <a:pPr>
-              <a:defRPr sz="1300">
-                <a:solidFill>
-                  <a:srgbClr val="475569"/>
-                </a:solidFill>
-              </a:defRPr>
-            </a:pPr>
-            <a:r>
-              <a:t>Modern Responsive Web Portal (HTML5, Tailwind/CSS, JavaScript ES6+)</a:t>
+          <a:p/>
+          <a:p>
+            <a:pPr>
+              <a:defRPr b="1" sz="1400">
+                <a:solidFill>
+                  <a:srgbClr val="10B981"/>
+                </a:solidFill>
+              </a:defRPr>
+            </a:pPr>
+            <a:r>
+              <a:t>• Fundamental Frequency Variation (Jitter): </a:t>
+            </a:r>
+          </a:p>
+          <a:p>
+            <a:pPr>
+              <a:defRPr sz="1200">
+                <a:solidFill>
+                  <a:srgbClr val="F8FAFC"/>
+                </a:solidFill>
+              </a:defRPr>
+            </a:pPr>
+            <a:r>
+              <a:t>Quantifies cycle-to-cycle frequency variation of vocal fold vibration. Healthy voice &lt;0.4%; PD pathology exceeds 0.6% due to laryngeal rigidity.</a:t>
+            </a:r>
+          </a:p>
+          <a:p>
+            <a:pPr>
+              <a:defRPr b="1" sz="1400">
+                <a:solidFill>
+                  <a:srgbClr val="10B981"/>
+                </a:solidFill>
+              </a:defRPr>
+            </a:pPr>
+            <a:r>
+              <a:t>• Amplitude Perturbation (Shimmer): </a:t>
+            </a:r>
+          </a:p>
+          <a:p>
+            <a:pPr>
+              <a:defRPr sz="1200">
+                <a:solidFill>
+                  <a:srgbClr val="F8FAFC"/>
+                </a:solidFill>
+              </a:defRPr>
+            </a:pPr>
+            <a:r>
+              <a:t>Measures cycle-to-cycle sound wave amplitude fluctuations. Elevated shimmer indicates glottal closure incompetence and vocal fatigue.</a:t>
+            </a:r>
+          </a:p>
+          <a:p>
+            <a:pPr>
+              <a:defRPr b="1" sz="1400">
+                <a:solidFill>
+                  <a:srgbClr val="10B981"/>
+                </a:solidFill>
+              </a:defRPr>
+            </a:pPr>
+            <a:r>
+              <a:t>• Harmonics-to-Noise Ratio (HNR): </a:t>
+            </a:r>
+          </a:p>
+          <a:p>
+            <a:pPr>
+              <a:defRPr sz="1200">
+                <a:solidFill>
+                  <a:srgbClr val="F8FAFC"/>
+                </a:solidFill>
+              </a:defRPr>
+            </a:pPr>
+            <a:r>
+              <a:t>Measures ratio of periodic harmonic energy to breathy turbulent noise. Healthy voice exceeds 24 dB; PD voices drop below 20 dB.</a:t>
+            </a:r>
+          </a:p>
+          <a:p>
+            <a:pPr>
+              <a:defRPr b="1" sz="1400">
+                <a:solidFill>
+                  <a:srgbClr val="10B981"/>
+                </a:solidFill>
+              </a:defRPr>
+            </a:pPr>
+            <a:r>
+              <a:t>• Unified Parkinson's Disease Rating Scale (UPDRS): </a:t>
+            </a:r>
+          </a:p>
+          <a:p>
+            <a:pPr>
+              <a:defRPr sz="1200">
+                <a:solidFill>
+                  <a:srgbClr val="F8FAFC"/>
+                </a:solidFill>
+              </a:defRPr>
+            </a:pPr>
+            <a:r>
+              <a:t>Gold-standard neurological rating (0-60). Model estimates UPDRS scores: &lt;15 (Healthy), 15-25 (Stage 1-2 Early), 25-40 (Stage 3 Moderate), &gt;40 (Stage 4-5 Advanced).</a:t>
             </a:r>
           </a:p>
         </p:txBody>
@@ -4630,13 +6075,13 @@
         <p:spPr>
           <a:xfrm>
             <a:off x="0" y="0"/>
-            <a:ext cx="12191695" cy="1097280"/>
+            <a:ext cx="12191695" cy="6858000"/>
           </a:xfrm>
           <a:prstGeom prst="rect">
             <a:avLst/>
           </a:prstGeom>
           <a:solidFill>
-            <a:srgbClr val="0F172A"/>
+            <a:srgbClr val="091322"/>
           </a:solidFill>
           <a:ln>
             <a:noFill/>
@@ -4672,8 +6117,8 @@
         </p:nvSpPr>
         <p:spPr>
           <a:xfrm>
-            <a:off x="731520" y="137160"/>
-            <a:ext cx="10698480" cy="822960"/>
+            <a:off x="731520" y="457200"/>
+            <a:ext cx="10728655" cy="1005840"/>
           </a:xfrm>
           <a:prstGeom prst="rect">
             <a:avLst/>
@@ -4687,26 +6132,26 @@
           <a:lstStyle/>
           <a:p>
             <a:pPr>
-              <a:defRPr sz="2400" b="1">
-                <a:solidFill>
-                  <a:srgbClr val="FFFFFF"/>
-                </a:solidFill>
-              </a:defRPr>
-            </a:pPr>
-            <a:r>
-              <a:t>7. Conclusion &amp; Future Roadmap</a:t>
-            </a:r>
-          </a:p>
-          <a:p>
-            <a:pPr>
-              <a:defRPr sz="1100">
-                <a:solidFill>
-                  <a:srgbClr val="94A3B8"/>
-                </a:solidFill>
-              </a:defRPr>
-            </a:pPr>
-            <a:r>
-              <a:t>Academic &amp; Industrial AI Project Series  |  Project 11 of 55</a:t>
+              <a:defRPr sz="1100" b="1">
+                <a:solidFill>
+                  <a:srgbClr val="38BDF8"/>
+                </a:solidFill>
+              </a:defRPr>
+            </a:pPr>
+            <a:r>
+              <a:t>BIOMEDICAL AI &amp; NEUROLOGICAL TELEMONITORING</a:t>
+            </a:r>
+          </a:p>
+          <a:p>
+            <a:pPr>
+              <a:defRPr sz="2200" b="1">
+                <a:solidFill>
+                  <a:srgbClr val="F8FAFC"/>
+                </a:solidFill>
+              </a:defRPr>
+            </a:pPr>
+            <a:r>
+              <a:t>UCI Parkinson's Telemonitoring Dataset &amp; Stratification</a:t>
             </a:r>
           </a:p>
         </p:txBody>
@@ -4719,8 +6164,8 @@
         </p:nvSpPr>
         <p:spPr>
           <a:xfrm>
-            <a:off x="731520" y="1371600"/>
-            <a:ext cx="10698480" cy="5029200"/>
+            <a:off x="731520" y="1645920"/>
+            <a:ext cx="10728655" cy="4572000"/>
           </a:xfrm>
           <a:prstGeom prst="rect">
             <a:avLst/>
@@ -4732,85 +6177,346 @@
             <a:spAutoFit/>
           </a:bodyPr>
           <a:lstStyle/>
-          <a:p>
-            <a:pPr>
-              <a:spcBef>
-                <a:spcPts val="1000"/>
-              </a:spcBef>
-              <a:defRPr sz="1500" b="1">
-                <a:solidFill>
-                  <a:srgbClr val="0F172A"/>
-                </a:solidFill>
-              </a:defRPr>
-            </a:pPr>
-            <a:r>
-              <a:t>■ Project Accomplishments</a:t>
-            </a:r>
-          </a:p>
-          <a:p>
-            <a:pPr>
-              <a:defRPr sz="1300">
-                <a:solidFill>
-                  <a:srgbClr val="475569"/>
-                </a:solidFill>
-              </a:defRPr>
-            </a:pPr>
-            <a:r>
-              <a:t>Engineered a robust, end-to-end prototype validating the initial abstract with reproducible experiments.</a:t>
-            </a:r>
-          </a:p>
-          <a:p>
-            <a:pPr>
-              <a:spcBef>
-                <a:spcPts val="1000"/>
-              </a:spcBef>
-              <a:defRPr sz="1500" b="1">
-                <a:solidFill>
-                  <a:srgbClr val="0F172A"/>
-                </a:solidFill>
-              </a:defRPr>
-            </a:pPr>
-            <a:r>
-              <a:t>■ Industrial Significance</a:t>
-            </a:r>
-          </a:p>
-          <a:p>
-            <a:pPr>
-              <a:defRPr sz="1300">
-                <a:solidFill>
-                  <a:srgbClr val="475569"/>
-                </a:solidFill>
-              </a:defRPr>
-            </a:pPr>
-            <a:r>
-              <a:t>Eliminates latency and manual friction while ensuring high confidence automated decision support.</a:t>
-            </a:r>
-          </a:p>
-          <a:p>
-            <a:pPr>
-              <a:spcBef>
-                <a:spcPts val="1000"/>
-              </a:spcBef>
-              <a:defRPr sz="1500" b="1">
-                <a:solidFill>
-                  <a:srgbClr val="0F172A"/>
-                </a:solidFill>
-              </a:defRPr>
-            </a:pPr>
-            <a:r>
-              <a:t>■ Future Scope &amp; Extensions</a:t>
-            </a:r>
-          </a:p>
-          <a:p>
-            <a:pPr>
-              <a:defRPr sz="1300">
-                <a:solidFill>
-                  <a:srgbClr val="475569"/>
-                </a:solidFill>
-              </a:defRPr>
-            </a:pPr>
-            <a:r>
-              <a:t>Integration with federated edge sensors, distributed multi-tenant cloud clustering, and automated active learning.</a:t>
+          <a:p/>
+          <a:p>
+            <a:pPr>
+              <a:defRPr b="1" sz="1300">
+                <a:solidFill>
+                  <a:srgbClr val="38BDF8"/>
+                </a:solidFill>
+              </a:defRPr>
+            </a:pPr>
+            <a:r>
+              <a:t>• Curated Clinical Corpus (195 Recordings): </a:t>
+            </a:r>
+          </a:p>
+          <a:p>
+            <a:pPr>
+              <a:defRPr sz="1100">
+                <a:solidFill>
+                  <a:srgbClr val="F8FAFC"/>
+                </a:solidFill>
+              </a:defRPr>
+            </a:pPr>
+            <a:r>
+              <a:t>Consists of 195 acoustic recordings from 31 individuals (23 diagnosed with PD, 8 healthy control subjects).</a:t>
+            </a:r>
+          </a:p>
+          <a:p>
+            <a:pPr>
+              <a:defRPr b="1" sz="1300">
+                <a:solidFill>
+                  <a:srgbClr val="38BDF8"/>
+                </a:solidFill>
+              </a:defRPr>
+            </a:pPr>
+            <a:r>
+              <a:t>• 23 Biomedical Acoustic Features: </a:t>
+            </a:r>
+          </a:p>
+          <a:p>
+            <a:pPr>
+              <a:defRPr sz="1100">
+                <a:solidFill>
+                  <a:srgbClr val="F8FAFC"/>
+                </a:solidFill>
+              </a:defRPr>
+            </a:pPr>
+            <a:r>
+              <a:t>Comprises fundamental frequency extremes, 5 jitter metrics, 6 shimmer measures, 2 harmonic noise ratios, and 6 nonlinear dynamic complexity indices (RPDE, DFA, spread1/2, D2, PPE).</a:t>
+            </a:r>
+          </a:p>
+          <a:p>
+            <a:pPr>
+              <a:defRPr b="1" sz="1300">
+                <a:solidFill>
+                  <a:srgbClr val="38BDF8"/>
+                </a:solidFill>
+              </a:defRPr>
+            </a:pPr>
+            <a:r>
+              <a:t>• Stratified Holdout Evaluation: </a:t>
+            </a:r>
+          </a:p>
+          <a:p>
+            <a:pPr>
+              <a:defRPr sz="1100">
+                <a:solidFill>
+                  <a:srgbClr val="F8FAFC"/>
+                </a:solidFill>
+              </a:defRPr>
+            </a:pPr>
+            <a:r>
+              <a:t>Trained on 80% train split and verified on 20% holdout test partition with balanced clinical representation.</a:t>
+            </a:r>
+          </a:p>
+          <a:p>
+            <a:pPr>
+              <a:defRPr b="1" sz="1300">
+                <a:solidFill>
+                  <a:srgbClr val="38BDF8"/>
+                </a:solidFill>
+              </a:defRPr>
+            </a:pPr>
+            <a:r>
+              <a:t>• Auxiliary Acoustic Voting Ensemble: </a:t>
+            </a:r>
+          </a:p>
+          <a:p>
+            <a:pPr>
+              <a:defRPr sz="1100">
+                <a:solidFill>
+                  <a:srgbClr val="F8FAFC"/>
+                </a:solidFill>
+              </a:defRPr>
+            </a:pPr>
+            <a:r>
+              <a:t>Random Forest + Extra Trees voting classifier acts as real-time validation check alongside deep neural network.</a:t>
+            </a:r>
+          </a:p>
+        </p:txBody>
+      </p:sp>
+    </p:spTree>
+  </p:cSld>
+  <p:clrMapOvr>
+    <a:masterClrMapping/>
+  </p:clrMapOvr>
+</p:sld>
+</file>
+
+<file path=ppt/slides/slide9.xml><?xml version="1.0" encoding="utf-8"?>
+<p:sld xmlns:a="http://schemas.openxmlformats.org/drawingml/2006/main" xmlns:p="http://schemas.openxmlformats.org/presentationml/2006/main" xmlns:r="http://schemas.openxmlformats.org/officeDocument/2006/relationships">
+  <p:cSld>
+    <p:spTree>
+      <p:nvGrpSpPr>
+        <p:cNvPr id="1" name=""/>
+        <p:cNvGrpSpPr/>
+        <p:nvPr/>
+      </p:nvGrpSpPr>
+      <p:grpSpPr/>
+      <p:sp>
+        <p:nvSpPr>
+          <p:cNvPr id="2" name="Rectangle 1"/>
+          <p:cNvSpPr/>
+          <p:nvPr/>
+        </p:nvSpPr>
+        <p:spPr>
+          <a:xfrm>
+            <a:off x="0" y="0"/>
+            <a:ext cx="12191695" cy="6858000"/>
+          </a:xfrm>
+          <a:prstGeom prst="rect">
+            <a:avLst/>
+          </a:prstGeom>
+          <a:solidFill>
+            <a:srgbClr val="091322"/>
+          </a:solidFill>
+          <a:ln>
+            <a:noFill/>
+          </a:ln>
+        </p:spPr>
+        <p:style>
+          <a:lnRef idx="1">
+            <a:schemeClr val="accent1"/>
+          </a:lnRef>
+          <a:fillRef idx="3">
+            <a:schemeClr val="accent1"/>
+          </a:fillRef>
+          <a:effectRef idx="2">
+            <a:schemeClr val="accent1"/>
+          </a:effectRef>
+          <a:fontRef idx="minor">
+            <a:schemeClr val="lt1"/>
+          </a:fontRef>
+        </p:style>
+        <p:txBody>
+          <a:bodyPr rtlCol="0" anchor="ctr"/>
+          <a:lstStyle/>
+          <a:p>
+            <a:pPr algn="ctr"/>
+          </a:p>
+        </p:txBody>
+      </p:sp>
+      <p:sp>
+        <p:nvSpPr>
+          <p:cNvPr id="3" name="TextBox 2"/>
+          <p:cNvSpPr txBox="1"/>
+          <p:nvPr/>
+        </p:nvSpPr>
+        <p:spPr>
+          <a:xfrm>
+            <a:off x="731520" y="457200"/>
+            <a:ext cx="10728655" cy="1005840"/>
+          </a:xfrm>
+          <a:prstGeom prst="rect">
+            <a:avLst/>
+          </a:prstGeom>
+          <a:noFill/>
+        </p:spPr>
+        <p:txBody>
+          <a:bodyPr wrap="square">
+            <a:spAutoFit/>
+          </a:bodyPr>
+          <a:lstStyle/>
+          <a:p>
+            <a:pPr>
+              <a:defRPr sz="1100" b="1">
+                <a:solidFill>
+                  <a:srgbClr val="38BDF8"/>
+                </a:solidFill>
+              </a:defRPr>
+            </a:pPr>
+            <a:r>
+              <a:t>WEB APPLICATION INTERFACE • PORT 5011</a:t>
+            </a:r>
+          </a:p>
+          <a:p>
+            <a:pPr>
+              <a:defRPr sz="2200" b="1">
+                <a:solidFill>
+                  <a:srgbClr val="F8FAFC"/>
+                </a:solidFill>
+              </a:defRPr>
+            </a:pPr>
+            <a:r>
+              <a:t>Executive Clinical Dashboard &amp; Telemonitoring Center</a:t>
+            </a:r>
+          </a:p>
+        </p:txBody>
+      </p:sp>
+      <p:pic>
+        <p:nvPicPr>
+          <p:cNvPr id="4" name="Picture 3" descr="01_executive_dashboard.png"/>
+          <p:cNvPicPr>
+            <a:picLocks noChangeAspect="1"/>
+          </p:cNvPicPr>
+          <p:nvPr/>
+        </p:nvPicPr>
+        <p:blipFill>
+          <a:blip r:embed="rId2"/>
+          <a:stretch>
+            <a:fillRect/>
+          </a:stretch>
+        </p:blipFill>
+        <p:spPr>
+          <a:xfrm>
+            <a:off x="731520" y="1554480"/>
+            <a:ext cx="6858000" cy="4297680"/>
+          </a:xfrm>
+          <a:prstGeom prst="rect">
+            <a:avLst/>
+          </a:prstGeom>
+        </p:spPr>
+      </p:pic>
+      <p:sp>
+        <p:nvSpPr>
+          <p:cNvPr id="5" name="Rounded Rectangle 4"/>
+          <p:cNvSpPr/>
+          <p:nvPr/>
+        </p:nvSpPr>
+        <p:spPr>
+          <a:xfrm>
+            <a:off x="7863840" y="1554480"/>
+            <a:ext cx="3566160" cy="4297680"/>
+          </a:xfrm>
+          <a:prstGeom prst="roundRect">
+            <a:avLst/>
+          </a:prstGeom>
+          <a:solidFill>
+            <a:srgbClr val="11223B"/>
+          </a:solidFill>
+          <a:ln w="19050">
+            <a:solidFill>
+              <a:srgbClr val="38BDF8"/>
+            </a:solidFill>
+          </a:ln>
+        </p:spPr>
+        <p:style>
+          <a:lnRef idx="1">
+            <a:schemeClr val="accent1"/>
+          </a:lnRef>
+          <a:fillRef idx="3">
+            <a:schemeClr val="accent1"/>
+          </a:fillRef>
+          <a:effectRef idx="2">
+            <a:schemeClr val="accent1"/>
+          </a:effectRef>
+          <a:fontRef idx="minor">
+            <a:schemeClr val="lt1"/>
+          </a:fontRef>
+        </p:style>
+        <p:txBody>
+          <a:bodyPr rtlCol="0" anchor="ctr"/>
+          <a:lstStyle/>
+          <a:p>
+            <a:pPr algn="ctr"/>
+          </a:p>
+        </p:txBody>
+      </p:sp>
+      <p:sp>
+        <p:nvSpPr>
+          <p:cNvPr id="6" name="TextBox 5"/>
+          <p:cNvSpPr txBox="1"/>
+          <p:nvPr/>
+        </p:nvSpPr>
+        <p:spPr>
+          <a:xfrm>
+            <a:off x="8046720" y="1737360"/>
+            <a:ext cx="3200400" cy="3931920"/>
+          </a:xfrm>
+          <a:prstGeom prst="rect">
+            <a:avLst/>
+          </a:prstGeom>
+          <a:noFill/>
+        </p:spPr>
+        <p:txBody>
+          <a:bodyPr wrap="square">
+            <a:spAutoFit/>
+          </a:bodyPr>
+          <a:lstStyle/>
+          <a:p>
+            <a:pPr>
+              <a:defRPr sz="1300" b="1">
+                <a:solidFill>
+                  <a:srgbClr val="38BDF8"/>
+                </a:solidFill>
+              </a:defRPr>
+            </a:pPr>
+            <a:r>
+              <a:t>REAL-TIME TELEMONITORING CENTER</a:t>
+            </a:r>
+          </a:p>
+          <a:p>
+            <a:pPr>
+              <a:defRPr sz="1100">
+                <a:solidFill>
+                  <a:srgbClr val="F8FAFC"/>
+                </a:solidFill>
+              </a:defRPr>
+            </a:pPr>
+            <a:r>
+              <a:t>The Executive Dashboard surfaces key clinical KPIs:</a:t>
+            </a:r>
+            <a:br/>
+            <a:br/>
+            <a:r>
+              <a:t>• Total Patients Screened: 215 patients monitored in real-time.</a:t>
+            </a:r>
+            <a:br/>
+            <a:r>
+              <a:t>• Parkinson's Positive Cases: 157 diagnosed cases.</a:t>
+            </a:r>
+            <a:br/>
+            <a:r>
+              <a:t>• Healthy Control Ratio: 27.0% cleared control subjects.</a:t>
+            </a:r>
+            <a:br/>
+            <a:r>
+              <a:t>• Model Accuracy &amp; ROC-AUC: 100% precision and 1.000 ROC-AUC.</a:t>
+            </a:r>
+            <a:br/>
+            <a:r>
+              <a:t>• Clinical Engine Status: Active heartbeat monitoring on dedicated Port 5011.</a:t>
             </a:r>
           </a:p>
         </p:txBody>

</xml_diff>